<commit_message>
Set bottom slide margin equal to right margin
Derive table height from the side margin so full slides keep the same
spacing on the right and bottom edges.

Co-authored-by: Artem Kostin <kostin.artem@gmail.com>
</commit_message>
<xml_diff>
--- a/Дефекты_и_разработки_по_Пилоту.pptx
+++ b/Дефекты_и_разработки_по_Пилоту.pptx
@@ -3162,7 +3162,7 @@
         </p:nvGraphicFramePr>
         <p:xfrm>
           <a:off x="533095" y="1030528"/>
-          <a:ext cx="11415367" cy="5488223"/>
+          <a:ext cx="11415367" cy="5583325"/>
         </p:xfrm>
         <a:graphic>
           <a:graphicData uri="http://schemas.openxmlformats.org/drawingml/2006/table">
@@ -3181,7 +3181,7 @@
               <a:tr h="738835">
                 <a:tc>
                   <a:txBody>
-                    <a:bodyPr/>
+                    <a:bodyPr wrap="square"/>
                     <a:lstStyle/>
                     <a:p>
                       <a:pPr algn="ctr">
@@ -3234,7 +3234,7 @@
                 </a:tc>
                 <a:tc>
                   <a:txBody>
-                    <a:bodyPr/>
+                    <a:bodyPr wrap="square"/>
                     <a:lstStyle/>
                     <a:p>
                       <a:pPr algn="ctr">
@@ -3287,7 +3287,7 @@
                 </a:tc>
                 <a:tc>
                   <a:txBody>
-                    <a:bodyPr/>
+                    <a:bodyPr wrap="square"/>
                     <a:lstStyle/>
                     <a:p>
                       <a:pPr algn="ctr">
@@ -3340,7 +3340,7 @@
                 </a:tc>
                 <a:tc>
                   <a:txBody>
-                    <a:bodyPr/>
+                    <a:bodyPr wrap="square"/>
                     <a:lstStyle/>
                     <a:p>
                       <a:pPr algn="ctr">
@@ -3393,7 +3393,7 @@
                 </a:tc>
                 <a:tc>
                   <a:txBody>
-                    <a:bodyPr/>
+                    <a:bodyPr wrap="square"/>
                     <a:lstStyle/>
                     <a:p>
                       <a:pPr algn="ctr">
@@ -3449,7 +3449,7 @@
                 </a:tc>
                 <a:tc>
                   <a:txBody>
-                    <a:bodyPr/>
+                    <a:bodyPr wrap="square"/>
                     <a:lstStyle/>
                     <a:p>
                       <a:pPr algn="ctr">
@@ -3501,10 +3501,10 @@
                   </a:tcPr>
                 </a:tc>
               </a:tr>
-              <a:tr h="678484">
-                <a:tc>
-                  <a:txBody>
-                    <a:bodyPr/>
+              <a:tr h="692070">
+                <a:tc>
+                  <a:txBody>
+                    <a:bodyPr wrap="square"/>
                     <a:lstStyle/>
                     <a:p>
                       <a:pPr algn="ctr">
@@ -3557,7 +3557,7 @@
                 </a:tc>
                 <a:tc>
                   <a:txBody>
-                    <a:bodyPr/>
+                    <a:bodyPr wrap="square"/>
                     <a:lstStyle/>
                     <a:p>
                       <a:pPr algn="l">
@@ -3610,7 +3610,7 @@
                 </a:tc>
                 <a:tc>
                   <a:txBody>
-                    <a:bodyPr/>
+                    <a:bodyPr wrap="square"/>
                     <a:lstStyle/>
                     <a:p>
                       <a:pPr algn="l">
@@ -3663,7 +3663,7 @@
                 </a:tc>
                 <a:tc>
                   <a:txBody>
-                    <a:bodyPr/>
+                    <a:bodyPr wrap="square"/>
                     <a:lstStyle/>
                     <a:p>
                       <a:pPr algn="l">
@@ -3716,7 +3716,7 @@
                 </a:tc>
                 <a:tc>
                   <a:txBody>
-                    <a:bodyPr/>
+                    <a:bodyPr wrap="square"/>
                     <a:lstStyle/>
                     <a:p>
                       <a:pPr algn="r">
@@ -3769,7 +3769,7 @@
                 </a:tc>
                 <a:tc>
                   <a:txBody>
-                    <a:bodyPr/>
+                    <a:bodyPr wrap="square"/>
                     <a:lstStyle/>
                     <a:p>
                       <a:pPr algn="l">
@@ -3821,10 +3821,10 @@
                   </a:tcPr>
                 </a:tc>
               </a:tr>
-              <a:tr h="678484">
-                <a:tc>
-                  <a:txBody>
-                    <a:bodyPr/>
+              <a:tr h="692070">
+                <a:tc>
+                  <a:txBody>
+                    <a:bodyPr wrap="square"/>
                     <a:lstStyle/>
                     <a:p>
                       <a:pPr algn="ctr">
@@ -3877,7 +3877,7 @@
                 </a:tc>
                 <a:tc>
                   <a:txBody>
-                    <a:bodyPr/>
+                    <a:bodyPr wrap="square"/>
                     <a:lstStyle/>
                     <a:p>
                       <a:pPr algn="l">
@@ -3930,7 +3930,7 @@
                 </a:tc>
                 <a:tc>
                   <a:txBody>
-                    <a:bodyPr/>
+                    <a:bodyPr wrap="square"/>
                     <a:lstStyle/>
                     <a:p>
                       <a:pPr algn="l">
@@ -3983,7 +3983,7 @@
                 </a:tc>
                 <a:tc>
                   <a:txBody>
-                    <a:bodyPr/>
+                    <a:bodyPr wrap="square"/>
                     <a:lstStyle/>
                     <a:p>
                       <a:pPr algn="l">
@@ -4036,7 +4036,7 @@
                 </a:tc>
                 <a:tc>
                   <a:txBody>
-                    <a:bodyPr/>
+                    <a:bodyPr wrap="square"/>
                     <a:lstStyle/>
                     <a:p>
                       <a:pPr algn="r">
@@ -4089,7 +4089,7 @@
                 </a:tc>
                 <a:tc>
                   <a:txBody>
-                    <a:bodyPr/>
+                    <a:bodyPr wrap="square"/>
                     <a:lstStyle/>
                     <a:p>
                       <a:pPr algn="l">
@@ -4141,10 +4141,10 @@
                   </a:tcPr>
                 </a:tc>
               </a:tr>
-              <a:tr h="678484">
-                <a:tc>
-                  <a:txBody>
-                    <a:bodyPr/>
+              <a:tr h="692070">
+                <a:tc>
+                  <a:txBody>
+                    <a:bodyPr wrap="square"/>
                     <a:lstStyle/>
                     <a:p>
                       <a:pPr algn="ctr">
@@ -4197,7 +4197,7 @@
                 </a:tc>
                 <a:tc>
                   <a:txBody>
-                    <a:bodyPr/>
+                    <a:bodyPr wrap="square"/>
                     <a:lstStyle/>
                     <a:p>
                       <a:pPr algn="l">
@@ -4250,7 +4250,7 @@
                 </a:tc>
                 <a:tc>
                   <a:txBody>
-                    <a:bodyPr/>
+                    <a:bodyPr wrap="square"/>
                     <a:lstStyle/>
                     <a:p>
                       <a:pPr algn="l">
@@ -4303,7 +4303,7 @@
                 </a:tc>
                 <a:tc>
                   <a:txBody>
-                    <a:bodyPr/>
+                    <a:bodyPr wrap="square"/>
                     <a:lstStyle/>
                     <a:p>
                       <a:pPr algn="l">
@@ -4356,7 +4356,7 @@
                 </a:tc>
                 <a:tc>
                   <a:txBody>
-                    <a:bodyPr/>
+                    <a:bodyPr wrap="square"/>
                     <a:lstStyle/>
                     <a:p>
                       <a:pPr algn="r">
@@ -4409,7 +4409,7 @@
                 </a:tc>
                 <a:tc>
                   <a:txBody>
-                    <a:bodyPr/>
+                    <a:bodyPr wrap="square"/>
                     <a:lstStyle/>
                     <a:p>
                       <a:pPr algn="l">
@@ -4461,10 +4461,10 @@
                   </a:tcPr>
                 </a:tc>
               </a:tr>
-              <a:tr h="678484">
-                <a:tc>
-                  <a:txBody>
-                    <a:bodyPr/>
+              <a:tr h="692070">
+                <a:tc>
+                  <a:txBody>
+                    <a:bodyPr wrap="square"/>
                     <a:lstStyle/>
                     <a:p>
                       <a:pPr algn="ctr">
@@ -4517,7 +4517,7 @@
                 </a:tc>
                 <a:tc>
                   <a:txBody>
-                    <a:bodyPr/>
+                    <a:bodyPr wrap="square"/>
                     <a:lstStyle/>
                     <a:p>
                       <a:pPr algn="l">
@@ -4570,7 +4570,7 @@
                 </a:tc>
                 <a:tc>
                   <a:txBody>
-                    <a:bodyPr/>
+                    <a:bodyPr wrap="square"/>
                     <a:lstStyle/>
                     <a:p>
                       <a:pPr algn="l">
@@ -4623,7 +4623,7 @@
                 </a:tc>
                 <a:tc>
                   <a:txBody>
-                    <a:bodyPr/>
+                    <a:bodyPr wrap="square"/>
                     <a:lstStyle/>
                     <a:p>
                       <a:pPr algn="l">
@@ -4676,7 +4676,7 @@
                 </a:tc>
                 <a:tc>
                   <a:txBody>
-                    <a:bodyPr/>
+                    <a:bodyPr wrap="square"/>
                     <a:lstStyle/>
                     <a:p>
                       <a:pPr algn="r">
@@ -4729,7 +4729,7 @@
                 </a:tc>
                 <a:tc>
                   <a:txBody>
-                    <a:bodyPr/>
+                    <a:bodyPr wrap="square"/>
                     <a:lstStyle/>
                     <a:p>
                       <a:pPr algn="l">
@@ -4781,10 +4781,10 @@
                   </a:tcPr>
                 </a:tc>
               </a:tr>
-              <a:tr h="678484">
-                <a:tc>
-                  <a:txBody>
-                    <a:bodyPr/>
+              <a:tr h="692070">
+                <a:tc>
+                  <a:txBody>
+                    <a:bodyPr wrap="square"/>
                     <a:lstStyle/>
                     <a:p>
                       <a:pPr algn="ctr">
@@ -4837,7 +4837,7 @@
                 </a:tc>
                 <a:tc>
                   <a:txBody>
-                    <a:bodyPr/>
+                    <a:bodyPr wrap="square"/>
                     <a:lstStyle/>
                     <a:p>
                       <a:pPr algn="l">
@@ -4890,7 +4890,7 @@
                 </a:tc>
                 <a:tc>
                   <a:txBody>
-                    <a:bodyPr/>
+                    <a:bodyPr wrap="square"/>
                     <a:lstStyle/>
                     <a:p>
                       <a:pPr algn="l">
@@ -4943,7 +4943,7 @@
                 </a:tc>
                 <a:tc>
                   <a:txBody>
-                    <a:bodyPr/>
+                    <a:bodyPr wrap="square"/>
                     <a:lstStyle/>
                     <a:p>
                       <a:pPr algn="l">
@@ -4996,7 +4996,7 @@
                 </a:tc>
                 <a:tc>
                   <a:txBody>
-                    <a:bodyPr/>
+                    <a:bodyPr wrap="square"/>
                     <a:lstStyle/>
                     <a:p>
                       <a:pPr algn="r">
@@ -5040,7 +5040,7 @@
                 </a:tc>
                 <a:tc>
                   <a:txBody>
-                    <a:bodyPr/>
+                    <a:bodyPr wrap="square"/>
                     <a:lstStyle/>
                     <a:p>
                       <a:pPr algn="l">
@@ -5092,10 +5092,10 @@
                   </a:tcPr>
                 </a:tc>
               </a:tr>
-              <a:tr h="678484">
-                <a:tc>
-                  <a:txBody>
-                    <a:bodyPr/>
+              <a:tr h="692070">
+                <a:tc>
+                  <a:txBody>
+                    <a:bodyPr wrap="square"/>
                     <a:lstStyle/>
                     <a:p>
                       <a:pPr algn="ctr">
@@ -5148,7 +5148,7 @@
                 </a:tc>
                 <a:tc>
                   <a:txBody>
-                    <a:bodyPr/>
+                    <a:bodyPr wrap="square"/>
                     <a:lstStyle/>
                     <a:p>
                       <a:pPr algn="l">
@@ -5201,7 +5201,7 @@
                 </a:tc>
                 <a:tc>
                   <a:txBody>
-                    <a:bodyPr/>
+                    <a:bodyPr wrap="square"/>
                     <a:lstStyle/>
                     <a:p>
                       <a:pPr algn="l">
@@ -5254,7 +5254,7 @@
                 </a:tc>
                 <a:tc>
                   <a:txBody>
-                    <a:bodyPr/>
+                    <a:bodyPr wrap="square"/>
                     <a:lstStyle/>
                     <a:p>
                       <a:pPr algn="l">
@@ -5307,7 +5307,7 @@
                 </a:tc>
                 <a:tc>
                   <a:txBody>
-                    <a:bodyPr/>
+                    <a:bodyPr wrap="square"/>
                     <a:lstStyle/>
                     <a:p>
                       <a:pPr algn="r">
@@ -5360,7 +5360,7 @@
                 </a:tc>
                 <a:tc>
                   <a:txBody>
-                    <a:bodyPr/>
+                    <a:bodyPr wrap="square"/>
                     <a:lstStyle/>
                     <a:p>
                       <a:pPr algn="l">
@@ -5412,10 +5412,10 @@
                   </a:tcPr>
                 </a:tc>
               </a:tr>
-              <a:tr h="678484">
-                <a:tc>
-                  <a:txBody>
-                    <a:bodyPr/>
+              <a:tr h="692070">
+                <a:tc>
+                  <a:txBody>
+                    <a:bodyPr wrap="square"/>
                     <a:lstStyle/>
                     <a:p>
                       <a:pPr algn="ctr">
@@ -5468,7 +5468,7 @@
                 </a:tc>
                 <a:tc>
                   <a:txBody>
-                    <a:bodyPr/>
+                    <a:bodyPr wrap="square"/>
                     <a:lstStyle/>
                     <a:p>
                       <a:pPr algn="l">
@@ -5521,7 +5521,7 @@
                 </a:tc>
                 <a:tc>
                   <a:txBody>
-                    <a:bodyPr/>
+                    <a:bodyPr wrap="square"/>
                     <a:lstStyle/>
                     <a:p>
                       <a:pPr algn="l">
@@ -5574,7 +5574,7 @@
                 </a:tc>
                 <a:tc>
                   <a:txBody>
-                    <a:bodyPr/>
+                    <a:bodyPr wrap="square"/>
                     <a:lstStyle/>
                     <a:p>
                       <a:pPr algn="l">
@@ -5627,7 +5627,7 @@
                 </a:tc>
                 <a:tc>
                   <a:txBody>
-                    <a:bodyPr/>
+                    <a:bodyPr wrap="square"/>
                     <a:lstStyle/>
                     <a:p>
                       <a:pPr algn="r">
@@ -5680,7 +5680,7 @@
                 </a:tc>
                 <a:tc>
                   <a:txBody>
-                    <a:bodyPr/>
+                    <a:bodyPr wrap="square"/>
                     <a:lstStyle/>
                     <a:p>
                       <a:pPr algn="l">
@@ -5823,7 +5823,7 @@
         </p:nvGraphicFramePr>
         <p:xfrm>
           <a:off x="533095" y="1030528"/>
-          <a:ext cx="11415367" cy="5488223"/>
+          <a:ext cx="11415367" cy="5583325"/>
         </p:xfrm>
         <a:graphic>
           <a:graphicData uri="http://schemas.openxmlformats.org/drawingml/2006/table">
@@ -5842,7 +5842,7 @@
               <a:tr h="738835">
                 <a:tc>
                   <a:txBody>
-                    <a:bodyPr/>
+                    <a:bodyPr wrap="square"/>
                     <a:lstStyle/>
                     <a:p>
                       <a:pPr algn="ctr">
@@ -5895,7 +5895,7 @@
                 </a:tc>
                 <a:tc>
                   <a:txBody>
-                    <a:bodyPr/>
+                    <a:bodyPr wrap="square"/>
                     <a:lstStyle/>
                     <a:p>
                       <a:pPr algn="ctr">
@@ -5948,7 +5948,7 @@
                 </a:tc>
                 <a:tc>
                   <a:txBody>
-                    <a:bodyPr/>
+                    <a:bodyPr wrap="square"/>
                     <a:lstStyle/>
                     <a:p>
                       <a:pPr algn="ctr">
@@ -6001,7 +6001,7 @@
                 </a:tc>
                 <a:tc>
                   <a:txBody>
-                    <a:bodyPr/>
+                    <a:bodyPr wrap="square"/>
                     <a:lstStyle/>
                     <a:p>
                       <a:pPr algn="ctr">
@@ -6054,7 +6054,7 @@
                 </a:tc>
                 <a:tc>
                   <a:txBody>
-                    <a:bodyPr/>
+                    <a:bodyPr wrap="square"/>
                     <a:lstStyle/>
                     <a:p>
                       <a:pPr algn="ctr">
@@ -6110,7 +6110,7 @@
                 </a:tc>
                 <a:tc>
                   <a:txBody>
-                    <a:bodyPr/>
+                    <a:bodyPr wrap="square"/>
                     <a:lstStyle/>
                     <a:p>
                       <a:pPr algn="ctr">
@@ -6162,10 +6162,10 @@
                   </a:tcPr>
                 </a:tc>
               </a:tr>
-              <a:tr h="678484">
-                <a:tc>
-                  <a:txBody>
-                    <a:bodyPr/>
+              <a:tr h="692070">
+                <a:tc>
+                  <a:txBody>
+                    <a:bodyPr wrap="square"/>
                     <a:lstStyle/>
                     <a:p>
                       <a:pPr algn="ctr">
@@ -6218,7 +6218,7 @@
                 </a:tc>
                 <a:tc>
                   <a:txBody>
-                    <a:bodyPr/>
+                    <a:bodyPr wrap="square"/>
                     <a:lstStyle/>
                     <a:p>
                       <a:pPr algn="l">
@@ -6271,7 +6271,7 @@
                 </a:tc>
                 <a:tc>
                   <a:txBody>
-                    <a:bodyPr/>
+                    <a:bodyPr wrap="square"/>
                     <a:lstStyle/>
                     <a:p>
                       <a:pPr algn="l">
@@ -6324,7 +6324,7 @@
                 </a:tc>
                 <a:tc>
                   <a:txBody>
-                    <a:bodyPr/>
+                    <a:bodyPr wrap="square"/>
                     <a:lstStyle/>
                     <a:p>
                       <a:pPr algn="l">
@@ -6377,7 +6377,7 @@
                 </a:tc>
                 <a:tc>
                   <a:txBody>
-                    <a:bodyPr/>
+                    <a:bodyPr wrap="square"/>
                     <a:lstStyle/>
                     <a:p>
                       <a:pPr algn="r">
@@ -6430,7 +6430,7 @@
                 </a:tc>
                 <a:tc>
                   <a:txBody>
-                    <a:bodyPr/>
+                    <a:bodyPr wrap="square"/>
                     <a:lstStyle/>
                     <a:p>
                       <a:pPr algn="l">
@@ -6482,10 +6482,10 @@
                   </a:tcPr>
                 </a:tc>
               </a:tr>
-              <a:tr h="678484">
-                <a:tc>
-                  <a:txBody>
-                    <a:bodyPr/>
+              <a:tr h="692070">
+                <a:tc>
+                  <a:txBody>
+                    <a:bodyPr wrap="square"/>
                     <a:lstStyle/>
                     <a:p>
                       <a:pPr algn="ctr">
@@ -6538,7 +6538,7 @@
                 </a:tc>
                 <a:tc>
                   <a:txBody>
-                    <a:bodyPr/>
+                    <a:bodyPr wrap="square"/>
                     <a:lstStyle/>
                     <a:p>
                       <a:pPr algn="l">
@@ -6591,7 +6591,7 @@
                 </a:tc>
                 <a:tc>
                   <a:txBody>
-                    <a:bodyPr/>
+                    <a:bodyPr wrap="square"/>
                     <a:lstStyle/>
                     <a:p>
                       <a:pPr algn="l">
@@ -6644,7 +6644,7 @@
                 </a:tc>
                 <a:tc>
                   <a:txBody>
-                    <a:bodyPr/>
+                    <a:bodyPr wrap="square"/>
                     <a:lstStyle/>
                     <a:p>
                       <a:pPr algn="l">
@@ -6697,7 +6697,7 @@
                 </a:tc>
                 <a:tc>
                   <a:txBody>
-                    <a:bodyPr/>
+                    <a:bodyPr wrap="square"/>
                     <a:lstStyle/>
                     <a:p>
                       <a:pPr algn="r">
@@ -6750,7 +6750,7 @@
                 </a:tc>
                 <a:tc>
                   <a:txBody>
-                    <a:bodyPr/>
+                    <a:bodyPr wrap="square"/>
                     <a:lstStyle/>
                     <a:p>
                       <a:pPr algn="l">
@@ -6802,10 +6802,10 @@
                   </a:tcPr>
                 </a:tc>
               </a:tr>
-              <a:tr h="678484">
-                <a:tc>
-                  <a:txBody>
-                    <a:bodyPr/>
+              <a:tr h="692070">
+                <a:tc>
+                  <a:txBody>
+                    <a:bodyPr wrap="square"/>
                     <a:lstStyle/>
                     <a:p>
                       <a:pPr algn="ctr">
@@ -6858,7 +6858,7 @@
                 </a:tc>
                 <a:tc>
                   <a:txBody>
-                    <a:bodyPr/>
+                    <a:bodyPr wrap="square"/>
                     <a:lstStyle/>
                     <a:p>
                       <a:pPr algn="l">
@@ -6911,7 +6911,7 @@
                 </a:tc>
                 <a:tc>
                   <a:txBody>
-                    <a:bodyPr/>
+                    <a:bodyPr wrap="square"/>
                     <a:lstStyle/>
                     <a:p>
                       <a:pPr algn="l">
@@ -6964,7 +6964,7 @@
                 </a:tc>
                 <a:tc>
                   <a:txBody>
-                    <a:bodyPr/>
+                    <a:bodyPr wrap="square"/>
                     <a:lstStyle/>
                     <a:p>
                       <a:pPr algn="l">
@@ -7017,7 +7017,7 @@
                 </a:tc>
                 <a:tc>
                   <a:txBody>
-                    <a:bodyPr/>
+                    <a:bodyPr wrap="square"/>
                     <a:lstStyle/>
                     <a:p>
                       <a:pPr algn="r">
@@ -7070,7 +7070,7 @@
                 </a:tc>
                 <a:tc>
                   <a:txBody>
-                    <a:bodyPr/>
+                    <a:bodyPr wrap="square"/>
                     <a:lstStyle/>
                     <a:p>
                       <a:pPr algn="l">
@@ -7122,10 +7122,10 @@
                   </a:tcPr>
                 </a:tc>
               </a:tr>
-              <a:tr h="678484">
-                <a:tc>
-                  <a:txBody>
-                    <a:bodyPr/>
+              <a:tr h="692070">
+                <a:tc>
+                  <a:txBody>
+                    <a:bodyPr wrap="square"/>
                     <a:lstStyle/>
                     <a:p>
                       <a:pPr algn="ctr">
@@ -7178,7 +7178,7 @@
                 </a:tc>
                 <a:tc>
                   <a:txBody>
-                    <a:bodyPr/>
+                    <a:bodyPr wrap="square"/>
                     <a:lstStyle/>
                     <a:p>
                       <a:pPr algn="l">
@@ -7231,7 +7231,7 @@
                 </a:tc>
                 <a:tc>
                   <a:txBody>
-                    <a:bodyPr/>
+                    <a:bodyPr wrap="square"/>
                     <a:lstStyle/>
                     <a:p>
                       <a:pPr algn="l">
@@ -7284,7 +7284,7 @@
                 </a:tc>
                 <a:tc>
                   <a:txBody>
-                    <a:bodyPr/>
+                    <a:bodyPr wrap="square"/>
                     <a:lstStyle/>
                     <a:p>
                       <a:pPr algn="l">
@@ -7337,7 +7337,7 @@
                 </a:tc>
                 <a:tc>
                   <a:txBody>
-                    <a:bodyPr/>
+                    <a:bodyPr wrap="square"/>
                     <a:lstStyle/>
                     <a:p>
                       <a:pPr algn="r">
@@ -7390,7 +7390,7 @@
                 </a:tc>
                 <a:tc>
                   <a:txBody>
-                    <a:bodyPr/>
+                    <a:bodyPr wrap="square"/>
                     <a:lstStyle/>
                     <a:p>
                       <a:pPr algn="l">
@@ -7442,10 +7442,10 @@
                   </a:tcPr>
                 </a:tc>
               </a:tr>
-              <a:tr h="678484">
-                <a:tc>
-                  <a:txBody>
-                    <a:bodyPr/>
+              <a:tr h="692070">
+                <a:tc>
+                  <a:txBody>
+                    <a:bodyPr wrap="square"/>
                     <a:lstStyle/>
                     <a:p>
                       <a:pPr algn="ctr">
@@ -7498,7 +7498,7 @@
                 </a:tc>
                 <a:tc>
                   <a:txBody>
-                    <a:bodyPr/>
+                    <a:bodyPr wrap="square"/>
                     <a:lstStyle/>
                     <a:p>
                       <a:pPr algn="l">
@@ -7551,7 +7551,7 @@
                 </a:tc>
                 <a:tc>
                   <a:txBody>
-                    <a:bodyPr/>
+                    <a:bodyPr wrap="square"/>
                     <a:lstStyle/>
                     <a:p>
                       <a:pPr algn="l">
@@ -7604,7 +7604,7 @@
                 </a:tc>
                 <a:tc>
                   <a:txBody>
-                    <a:bodyPr/>
+                    <a:bodyPr wrap="square"/>
                     <a:lstStyle/>
                     <a:p>
                       <a:pPr algn="l">
@@ -7657,7 +7657,7 @@
                 </a:tc>
                 <a:tc>
                   <a:txBody>
-                    <a:bodyPr/>
+                    <a:bodyPr wrap="square"/>
                     <a:lstStyle/>
                     <a:p>
                       <a:pPr algn="r">
@@ -7710,7 +7710,7 @@
                 </a:tc>
                 <a:tc>
                   <a:txBody>
-                    <a:bodyPr/>
+                    <a:bodyPr wrap="square"/>
                     <a:lstStyle/>
                     <a:p>
                       <a:pPr algn="l">
@@ -7762,10 +7762,10 @@
                   </a:tcPr>
                 </a:tc>
               </a:tr>
-              <a:tr h="678484">
-                <a:tc>
-                  <a:txBody>
-                    <a:bodyPr/>
+              <a:tr h="692070">
+                <a:tc>
+                  <a:txBody>
+                    <a:bodyPr wrap="square"/>
                     <a:lstStyle/>
                     <a:p>
                       <a:pPr algn="ctr">
@@ -7818,7 +7818,7 @@
                 </a:tc>
                 <a:tc>
                   <a:txBody>
-                    <a:bodyPr/>
+                    <a:bodyPr wrap="square"/>
                     <a:lstStyle/>
                     <a:p>
                       <a:pPr algn="l">
@@ -7871,7 +7871,7 @@
                 </a:tc>
                 <a:tc>
                   <a:txBody>
-                    <a:bodyPr/>
+                    <a:bodyPr wrap="square"/>
                     <a:lstStyle/>
                     <a:p>
                       <a:pPr algn="l">
@@ -7924,7 +7924,7 @@
                 </a:tc>
                 <a:tc>
                   <a:txBody>
-                    <a:bodyPr/>
+                    <a:bodyPr wrap="square"/>
                     <a:lstStyle/>
                     <a:p>
                       <a:pPr algn="l">
@@ -7977,7 +7977,7 @@
                 </a:tc>
                 <a:tc>
                   <a:txBody>
-                    <a:bodyPr/>
+                    <a:bodyPr wrap="square"/>
                     <a:lstStyle/>
                     <a:p>
                       <a:pPr algn="r">
@@ -8030,7 +8030,7 @@
                 </a:tc>
                 <a:tc>
                   <a:txBody>
-                    <a:bodyPr/>
+                    <a:bodyPr wrap="square"/>
                     <a:lstStyle/>
                     <a:p>
                       <a:pPr algn="l">
@@ -8082,10 +8082,10 @@
                   </a:tcPr>
                 </a:tc>
               </a:tr>
-              <a:tr h="678484">
-                <a:tc>
-                  <a:txBody>
-                    <a:bodyPr/>
+              <a:tr h="692070">
+                <a:tc>
+                  <a:txBody>
+                    <a:bodyPr wrap="square"/>
                     <a:lstStyle/>
                     <a:p>
                       <a:pPr algn="ctr">
@@ -8138,7 +8138,7 @@
                 </a:tc>
                 <a:tc>
                   <a:txBody>
-                    <a:bodyPr/>
+                    <a:bodyPr wrap="square"/>
                     <a:lstStyle/>
                     <a:p>
                       <a:pPr algn="l">
@@ -8191,7 +8191,7 @@
                 </a:tc>
                 <a:tc>
                   <a:txBody>
-                    <a:bodyPr/>
+                    <a:bodyPr wrap="square"/>
                     <a:lstStyle/>
                     <a:p>
                       <a:pPr algn="l">
@@ -8244,7 +8244,7 @@
                 </a:tc>
                 <a:tc>
                   <a:txBody>
-                    <a:bodyPr/>
+                    <a:bodyPr wrap="square"/>
                     <a:lstStyle/>
                     <a:p>
                       <a:pPr algn="l">
@@ -8297,7 +8297,7 @@
                 </a:tc>
                 <a:tc>
                   <a:txBody>
-                    <a:bodyPr/>
+                    <a:bodyPr wrap="square"/>
                     <a:lstStyle/>
                     <a:p>
                       <a:pPr algn="r">
@@ -8350,7 +8350,7 @@
                 </a:tc>
                 <a:tc>
                   <a:txBody>
-                    <a:bodyPr/>
+                    <a:bodyPr wrap="square"/>
                     <a:lstStyle/>
                     <a:p>
                       <a:pPr algn="l">
@@ -8493,7 +8493,7 @@
         </p:nvGraphicFramePr>
         <p:xfrm>
           <a:off x="533095" y="1030528"/>
-          <a:ext cx="11415367" cy="5488223"/>
+          <a:ext cx="11415367" cy="5583325"/>
         </p:xfrm>
         <a:graphic>
           <a:graphicData uri="http://schemas.openxmlformats.org/drawingml/2006/table">
@@ -8512,7 +8512,7 @@
               <a:tr h="738835">
                 <a:tc>
                   <a:txBody>
-                    <a:bodyPr/>
+                    <a:bodyPr wrap="square"/>
                     <a:lstStyle/>
                     <a:p>
                       <a:pPr algn="ctr">
@@ -8565,7 +8565,7 @@
                 </a:tc>
                 <a:tc>
                   <a:txBody>
-                    <a:bodyPr/>
+                    <a:bodyPr wrap="square"/>
                     <a:lstStyle/>
                     <a:p>
                       <a:pPr algn="ctr">
@@ -8618,7 +8618,7 @@
                 </a:tc>
                 <a:tc>
                   <a:txBody>
-                    <a:bodyPr/>
+                    <a:bodyPr wrap="square"/>
                     <a:lstStyle/>
                     <a:p>
                       <a:pPr algn="ctr">
@@ -8671,7 +8671,7 @@
                 </a:tc>
                 <a:tc>
                   <a:txBody>
-                    <a:bodyPr/>
+                    <a:bodyPr wrap="square"/>
                     <a:lstStyle/>
                     <a:p>
                       <a:pPr algn="ctr">
@@ -8724,7 +8724,7 @@
                 </a:tc>
                 <a:tc>
                   <a:txBody>
-                    <a:bodyPr/>
+                    <a:bodyPr wrap="square"/>
                     <a:lstStyle/>
                     <a:p>
                       <a:pPr algn="ctr">
@@ -8780,7 +8780,7 @@
                 </a:tc>
                 <a:tc>
                   <a:txBody>
-                    <a:bodyPr/>
+                    <a:bodyPr wrap="square"/>
                     <a:lstStyle/>
                     <a:p>
                       <a:pPr algn="ctr">
@@ -8832,10 +8832,10 @@
                   </a:tcPr>
                 </a:tc>
               </a:tr>
-              <a:tr h="678484">
-                <a:tc>
-                  <a:txBody>
-                    <a:bodyPr/>
+              <a:tr h="692070">
+                <a:tc>
+                  <a:txBody>
+                    <a:bodyPr wrap="square"/>
                     <a:lstStyle/>
                     <a:p>
                       <a:pPr algn="ctr">
@@ -8888,7 +8888,7 @@
                 </a:tc>
                 <a:tc>
                   <a:txBody>
-                    <a:bodyPr/>
+                    <a:bodyPr wrap="square"/>
                     <a:lstStyle/>
                     <a:p>
                       <a:pPr algn="l">
@@ -8941,7 +8941,7 @@
                 </a:tc>
                 <a:tc>
                   <a:txBody>
-                    <a:bodyPr/>
+                    <a:bodyPr wrap="square"/>
                     <a:lstStyle/>
                     <a:p>
                       <a:pPr algn="l">
@@ -8994,7 +8994,7 @@
                 </a:tc>
                 <a:tc>
                   <a:txBody>
-                    <a:bodyPr/>
+                    <a:bodyPr wrap="square"/>
                     <a:lstStyle/>
                     <a:p>
                       <a:pPr algn="l">
@@ -9047,7 +9047,7 @@
                 </a:tc>
                 <a:tc>
                   <a:txBody>
-                    <a:bodyPr/>
+                    <a:bodyPr wrap="square"/>
                     <a:lstStyle/>
                     <a:p>
                       <a:pPr algn="r">
@@ -9100,7 +9100,7 @@
                 </a:tc>
                 <a:tc>
                   <a:txBody>
-                    <a:bodyPr/>
+                    <a:bodyPr wrap="square"/>
                     <a:lstStyle/>
                     <a:p>
                       <a:pPr algn="l">
@@ -9152,10 +9152,10 @@
                   </a:tcPr>
                 </a:tc>
               </a:tr>
-              <a:tr h="678484">
-                <a:tc>
-                  <a:txBody>
-                    <a:bodyPr/>
+              <a:tr h="692070">
+                <a:tc>
+                  <a:txBody>
+                    <a:bodyPr wrap="square"/>
                     <a:lstStyle/>
                     <a:p>
                       <a:pPr algn="ctr">
@@ -9208,7 +9208,7 @@
                 </a:tc>
                 <a:tc>
                   <a:txBody>
-                    <a:bodyPr/>
+                    <a:bodyPr wrap="square"/>
                     <a:lstStyle/>
                     <a:p>
                       <a:pPr algn="l">
@@ -9261,7 +9261,7 @@
                 </a:tc>
                 <a:tc>
                   <a:txBody>
-                    <a:bodyPr/>
+                    <a:bodyPr wrap="square"/>
                     <a:lstStyle/>
                     <a:p>
                       <a:pPr algn="l">
@@ -9314,7 +9314,7 @@
                 </a:tc>
                 <a:tc>
                   <a:txBody>
-                    <a:bodyPr/>
+                    <a:bodyPr wrap="square"/>
                     <a:lstStyle/>
                     <a:p>
                       <a:pPr algn="l">
@@ -9367,7 +9367,7 @@
                 </a:tc>
                 <a:tc>
                   <a:txBody>
-                    <a:bodyPr/>
+                    <a:bodyPr wrap="square"/>
                     <a:lstStyle/>
                     <a:p>
                       <a:pPr algn="r">
@@ -9420,7 +9420,7 @@
                 </a:tc>
                 <a:tc>
                   <a:txBody>
-                    <a:bodyPr/>
+                    <a:bodyPr wrap="square"/>
                     <a:lstStyle/>
                     <a:p>
                       <a:pPr algn="l">
@@ -9472,10 +9472,10 @@
                   </a:tcPr>
                 </a:tc>
               </a:tr>
-              <a:tr h="678484">
-                <a:tc>
-                  <a:txBody>
-                    <a:bodyPr/>
+              <a:tr h="692070">
+                <a:tc>
+                  <a:txBody>
+                    <a:bodyPr wrap="square"/>
                     <a:lstStyle/>
                     <a:p>
                       <a:pPr algn="ctr">
@@ -9528,7 +9528,7 @@
                 </a:tc>
                 <a:tc>
                   <a:txBody>
-                    <a:bodyPr/>
+                    <a:bodyPr wrap="square"/>
                     <a:lstStyle/>
                     <a:p>
                       <a:pPr algn="l">
@@ -9581,7 +9581,7 @@
                 </a:tc>
                 <a:tc>
                   <a:txBody>
-                    <a:bodyPr/>
+                    <a:bodyPr wrap="square"/>
                     <a:lstStyle/>
                     <a:p>
                       <a:pPr algn="l">
@@ -9634,7 +9634,7 @@
                 </a:tc>
                 <a:tc>
                   <a:txBody>
-                    <a:bodyPr/>
+                    <a:bodyPr wrap="square"/>
                     <a:lstStyle/>
                     <a:p>
                       <a:pPr algn="l">
@@ -9687,7 +9687,7 @@
                 </a:tc>
                 <a:tc>
                   <a:txBody>
-                    <a:bodyPr/>
+                    <a:bodyPr wrap="square"/>
                     <a:lstStyle/>
                     <a:p>
                       <a:pPr algn="r">
@@ -9740,7 +9740,7 @@
                 </a:tc>
                 <a:tc>
                   <a:txBody>
-                    <a:bodyPr/>
+                    <a:bodyPr wrap="square"/>
                     <a:lstStyle/>
                     <a:p>
                       <a:pPr algn="l">
@@ -9792,10 +9792,10 @@
                   </a:tcPr>
                 </a:tc>
               </a:tr>
-              <a:tr h="678484">
-                <a:tc>
-                  <a:txBody>
-                    <a:bodyPr/>
+              <a:tr h="692070">
+                <a:tc>
+                  <a:txBody>
+                    <a:bodyPr wrap="square"/>
                     <a:lstStyle/>
                     <a:p>
                       <a:pPr algn="ctr">
@@ -9848,7 +9848,7 @@
                 </a:tc>
                 <a:tc>
                   <a:txBody>
-                    <a:bodyPr/>
+                    <a:bodyPr wrap="square"/>
                     <a:lstStyle/>
                     <a:p>
                       <a:pPr algn="l">
@@ -9901,7 +9901,7 @@
                 </a:tc>
                 <a:tc>
                   <a:txBody>
-                    <a:bodyPr/>
+                    <a:bodyPr wrap="square"/>
                     <a:lstStyle/>
                     <a:p>
                       <a:pPr algn="l">
@@ -9954,7 +9954,7 @@
                 </a:tc>
                 <a:tc>
                   <a:txBody>
-                    <a:bodyPr/>
+                    <a:bodyPr wrap="square"/>
                     <a:lstStyle/>
                     <a:p>
                       <a:pPr algn="l">
@@ -10007,7 +10007,7 @@
                 </a:tc>
                 <a:tc>
                   <a:txBody>
-                    <a:bodyPr/>
+                    <a:bodyPr wrap="square"/>
                     <a:lstStyle/>
                     <a:p>
                       <a:pPr algn="r">
@@ -10060,7 +10060,7 @@
                 </a:tc>
                 <a:tc>
                   <a:txBody>
-                    <a:bodyPr/>
+                    <a:bodyPr wrap="square"/>
                     <a:lstStyle/>
                     <a:p>
                       <a:pPr algn="l">
@@ -10112,10 +10112,10 @@
                   </a:tcPr>
                 </a:tc>
               </a:tr>
-              <a:tr h="678484">
-                <a:tc>
-                  <a:txBody>
-                    <a:bodyPr/>
+              <a:tr h="692070">
+                <a:tc>
+                  <a:txBody>
+                    <a:bodyPr wrap="square"/>
                     <a:lstStyle/>
                     <a:p>
                       <a:pPr algn="ctr">
@@ -10168,7 +10168,7 @@
                 </a:tc>
                 <a:tc>
                   <a:txBody>
-                    <a:bodyPr/>
+                    <a:bodyPr wrap="square"/>
                     <a:lstStyle/>
                     <a:p>
                       <a:pPr algn="l">
@@ -10221,7 +10221,7 @@
                 </a:tc>
                 <a:tc>
                   <a:txBody>
-                    <a:bodyPr/>
+                    <a:bodyPr wrap="square"/>
                     <a:lstStyle/>
                     <a:p>
                       <a:pPr algn="l">
@@ -10274,7 +10274,7 @@
                 </a:tc>
                 <a:tc>
                   <a:txBody>
-                    <a:bodyPr/>
+                    <a:bodyPr wrap="square"/>
                     <a:lstStyle/>
                     <a:p>
                       <a:pPr algn="l">
@@ -10327,7 +10327,7 @@
                 </a:tc>
                 <a:tc>
                   <a:txBody>
-                    <a:bodyPr/>
+                    <a:bodyPr wrap="square"/>
                     <a:lstStyle/>
                     <a:p>
                       <a:pPr algn="r">
@@ -10380,7 +10380,7 @@
                 </a:tc>
                 <a:tc>
                   <a:txBody>
-                    <a:bodyPr/>
+                    <a:bodyPr wrap="square"/>
                     <a:lstStyle/>
                     <a:p>
                       <a:pPr algn="l">
@@ -10432,10 +10432,10 @@
                   </a:tcPr>
                 </a:tc>
               </a:tr>
-              <a:tr h="678484">
-                <a:tc>
-                  <a:txBody>
-                    <a:bodyPr/>
+              <a:tr h="692070">
+                <a:tc>
+                  <a:txBody>
+                    <a:bodyPr wrap="square"/>
                     <a:lstStyle/>
                     <a:p>
                       <a:pPr algn="ctr">
@@ -10488,7 +10488,7 @@
                 </a:tc>
                 <a:tc>
                   <a:txBody>
-                    <a:bodyPr/>
+                    <a:bodyPr wrap="square"/>
                     <a:lstStyle/>
                     <a:p>
                       <a:pPr algn="l">
@@ -10541,7 +10541,7 @@
                 </a:tc>
                 <a:tc>
                   <a:txBody>
-                    <a:bodyPr/>
+                    <a:bodyPr wrap="square"/>
                     <a:lstStyle/>
                     <a:p>
                       <a:pPr algn="l">
@@ -10594,7 +10594,7 @@
                 </a:tc>
                 <a:tc>
                   <a:txBody>
-                    <a:bodyPr/>
+                    <a:bodyPr wrap="square"/>
                     <a:lstStyle/>
                     <a:p>
                       <a:pPr algn="l">
@@ -10647,7 +10647,7 @@
                 </a:tc>
                 <a:tc>
                   <a:txBody>
-                    <a:bodyPr/>
+                    <a:bodyPr wrap="square"/>
                     <a:lstStyle/>
                     <a:p>
                       <a:pPr algn="r">
@@ -10700,7 +10700,7 @@
                 </a:tc>
                 <a:tc>
                   <a:txBody>
-                    <a:bodyPr/>
+                    <a:bodyPr wrap="square"/>
                     <a:lstStyle/>
                     <a:p>
                       <a:pPr algn="l">
@@ -10752,10 +10752,10 @@
                   </a:tcPr>
                 </a:tc>
               </a:tr>
-              <a:tr h="678484">
-                <a:tc>
-                  <a:txBody>
-                    <a:bodyPr/>
+              <a:tr h="692070">
+                <a:tc>
+                  <a:txBody>
+                    <a:bodyPr wrap="square"/>
                     <a:lstStyle/>
                     <a:p>
                       <a:pPr algn="ctr">
@@ -10808,7 +10808,7 @@
                 </a:tc>
                 <a:tc>
                   <a:txBody>
-                    <a:bodyPr/>
+                    <a:bodyPr wrap="square"/>
                     <a:lstStyle/>
                     <a:p>
                       <a:pPr algn="l">
@@ -10861,7 +10861,7 @@
                 </a:tc>
                 <a:tc>
                   <a:txBody>
-                    <a:bodyPr/>
+                    <a:bodyPr wrap="square"/>
                     <a:lstStyle/>
                     <a:p>
                       <a:pPr algn="l">
@@ -10914,7 +10914,7 @@
                 </a:tc>
                 <a:tc>
                   <a:txBody>
-                    <a:bodyPr/>
+                    <a:bodyPr wrap="square"/>
                     <a:lstStyle/>
                     <a:p>
                       <a:pPr algn="l">
@@ -10967,7 +10967,7 @@
                 </a:tc>
                 <a:tc>
                   <a:txBody>
-                    <a:bodyPr/>
+                    <a:bodyPr wrap="square"/>
                     <a:lstStyle/>
                     <a:p>
                       <a:pPr algn="r">
@@ -11020,7 +11020,7 @@
                 </a:tc>
                 <a:tc>
                   <a:txBody>
-                    <a:bodyPr/>
+                    <a:bodyPr wrap="square"/>
                     <a:lstStyle/>
                     <a:p>
                       <a:pPr algn="l">
@@ -11163,7 +11163,7 @@
         </p:nvGraphicFramePr>
         <p:xfrm>
           <a:off x="533095" y="1030528"/>
-          <a:ext cx="11415367" cy="5488223"/>
+          <a:ext cx="11415367" cy="5583325"/>
         </p:xfrm>
         <a:graphic>
           <a:graphicData uri="http://schemas.openxmlformats.org/drawingml/2006/table">
@@ -11182,7 +11182,7 @@
               <a:tr h="738835">
                 <a:tc>
                   <a:txBody>
-                    <a:bodyPr/>
+                    <a:bodyPr wrap="square"/>
                     <a:lstStyle/>
                     <a:p>
                       <a:pPr algn="ctr">
@@ -11235,7 +11235,7 @@
                 </a:tc>
                 <a:tc>
                   <a:txBody>
-                    <a:bodyPr/>
+                    <a:bodyPr wrap="square"/>
                     <a:lstStyle/>
                     <a:p>
                       <a:pPr algn="ctr">
@@ -11288,7 +11288,7 @@
                 </a:tc>
                 <a:tc>
                   <a:txBody>
-                    <a:bodyPr/>
+                    <a:bodyPr wrap="square"/>
                     <a:lstStyle/>
                     <a:p>
                       <a:pPr algn="ctr">
@@ -11341,7 +11341,7 @@
                 </a:tc>
                 <a:tc>
                   <a:txBody>
-                    <a:bodyPr/>
+                    <a:bodyPr wrap="square"/>
                     <a:lstStyle/>
                     <a:p>
                       <a:pPr algn="ctr">
@@ -11394,7 +11394,7 @@
                 </a:tc>
                 <a:tc>
                   <a:txBody>
-                    <a:bodyPr/>
+                    <a:bodyPr wrap="square"/>
                     <a:lstStyle/>
                     <a:p>
                       <a:pPr algn="ctr">
@@ -11450,7 +11450,7 @@
                 </a:tc>
                 <a:tc>
                   <a:txBody>
-                    <a:bodyPr/>
+                    <a:bodyPr wrap="square"/>
                     <a:lstStyle/>
                     <a:p>
                       <a:pPr algn="ctr">
@@ -11502,10 +11502,10 @@
                   </a:tcPr>
                 </a:tc>
               </a:tr>
-              <a:tr h="678484">
-                <a:tc>
-                  <a:txBody>
-                    <a:bodyPr/>
+              <a:tr h="692070">
+                <a:tc>
+                  <a:txBody>
+                    <a:bodyPr wrap="square"/>
                     <a:lstStyle/>
                     <a:p>
                       <a:pPr algn="ctr">
@@ -11558,7 +11558,7 @@
                 </a:tc>
                 <a:tc>
                   <a:txBody>
-                    <a:bodyPr/>
+                    <a:bodyPr wrap="square"/>
                     <a:lstStyle/>
                     <a:p>
                       <a:pPr algn="l">
@@ -11611,7 +11611,7 @@
                 </a:tc>
                 <a:tc>
                   <a:txBody>
-                    <a:bodyPr/>
+                    <a:bodyPr wrap="square"/>
                     <a:lstStyle/>
                     <a:p>
                       <a:pPr algn="l">
@@ -11664,7 +11664,7 @@
                 </a:tc>
                 <a:tc>
                   <a:txBody>
-                    <a:bodyPr/>
+                    <a:bodyPr wrap="square"/>
                     <a:lstStyle/>
                     <a:p>
                       <a:pPr algn="l">
@@ -11717,7 +11717,7 @@
                 </a:tc>
                 <a:tc>
                   <a:txBody>
-                    <a:bodyPr/>
+                    <a:bodyPr wrap="square"/>
                     <a:lstStyle/>
                     <a:p>
                       <a:pPr algn="r">
@@ -11770,7 +11770,7 @@
                 </a:tc>
                 <a:tc>
                   <a:txBody>
-                    <a:bodyPr/>
+                    <a:bodyPr wrap="square"/>
                     <a:lstStyle/>
                     <a:p>
                       <a:pPr algn="l">
@@ -11822,10 +11822,10 @@
                   </a:tcPr>
                 </a:tc>
               </a:tr>
-              <a:tr h="678484">
-                <a:tc>
-                  <a:txBody>
-                    <a:bodyPr/>
+              <a:tr h="692070">
+                <a:tc>
+                  <a:txBody>
+                    <a:bodyPr wrap="square"/>
                     <a:lstStyle/>
                     <a:p>
                       <a:pPr algn="ctr">
@@ -11878,7 +11878,7 @@
                 </a:tc>
                 <a:tc>
                   <a:txBody>
-                    <a:bodyPr/>
+                    <a:bodyPr wrap="square"/>
                     <a:lstStyle/>
                     <a:p>
                       <a:pPr algn="l">
@@ -11931,7 +11931,7 @@
                 </a:tc>
                 <a:tc>
                   <a:txBody>
-                    <a:bodyPr/>
+                    <a:bodyPr wrap="square"/>
                     <a:lstStyle/>
                     <a:p>
                       <a:pPr algn="l">
@@ -11984,7 +11984,7 @@
                 </a:tc>
                 <a:tc>
                   <a:txBody>
-                    <a:bodyPr/>
+                    <a:bodyPr wrap="square"/>
                     <a:lstStyle/>
                     <a:p>
                       <a:pPr algn="l">
@@ -12037,7 +12037,7 @@
                 </a:tc>
                 <a:tc>
                   <a:txBody>
-                    <a:bodyPr/>
+                    <a:bodyPr wrap="square"/>
                     <a:lstStyle/>
                     <a:p>
                       <a:pPr algn="r">
@@ -12090,7 +12090,7 @@
                 </a:tc>
                 <a:tc>
                   <a:txBody>
-                    <a:bodyPr/>
+                    <a:bodyPr wrap="square"/>
                     <a:lstStyle/>
                     <a:p>
                       <a:pPr algn="l">
@@ -12142,10 +12142,10 @@
                   </a:tcPr>
                 </a:tc>
               </a:tr>
-              <a:tr h="678484">
-                <a:tc>
-                  <a:txBody>
-                    <a:bodyPr/>
+              <a:tr h="692070">
+                <a:tc>
+                  <a:txBody>
+                    <a:bodyPr wrap="square"/>
                     <a:lstStyle/>
                     <a:p>
                       <a:pPr algn="ctr">
@@ -12198,7 +12198,7 @@
                 </a:tc>
                 <a:tc>
                   <a:txBody>
-                    <a:bodyPr/>
+                    <a:bodyPr wrap="square"/>
                     <a:lstStyle/>
                     <a:p>
                       <a:pPr algn="l">
@@ -12251,7 +12251,7 @@
                 </a:tc>
                 <a:tc>
                   <a:txBody>
-                    <a:bodyPr/>
+                    <a:bodyPr wrap="square"/>
                     <a:lstStyle/>
                     <a:p>
                       <a:pPr algn="l">
@@ -12304,7 +12304,7 @@
                 </a:tc>
                 <a:tc>
                   <a:txBody>
-                    <a:bodyPr/>
+                    <a:bodyPr wrap="square"/>
                     <a:lstStyle/>
                     <a:p>
                       <a:pPr algn="l">
@@ -12357,7 +12357,7 @@
                 </a:tc>
                 <a:tc>
                   <a:txBody>
-                    <a:bodyPr/>
+                    <a:bodyPr wrap="square"/>
                     <a:lstStyle/>
                     <a:p>
                       <a:pPr algn="r">
@@ -12401,7 +12401,7 @@
                 </a:tc>
                 <a:tc>
                   <a:txBody>
-                    <a:bodyPr/>
+                    <a:bodyPr wrap="square"/>
                     <a:lstStyle/>
                     <a:p>
                       <a:pPr algn="l">
@@ -12453,10 +12453,10 @@
                   </a:tcPr>
                 </a:tc>
               </a:tr>
-              <a:tr h="678484">
-                <a:tc>
-                  <a:txBody>
-                    <a:bodyPr/>
+              <a:tr h="692070">
+                <a:tc>
+                  <a:txBody>
+                    <a:bodyPr wrap="square"/>
                     <a:lstStyle/>
                     <a:p>
                       <a:pPr algn="ctr">
@@ -12509,7 +12509,7 @@
                 </a:tc>
                 <a:tc>
                   <a:txBody>
-                    <a:bodyPr/>
+                    <a:bodyPr wrap="square"/>
                     <a:lstStyle/>
                     <a:p>
                       <a:pPr algn="l">
@@ -12562,7 +12562,7 @@
                 </a:tc>
                 <a:tc>
                   <a:txBody>
-                    <a:bodyPr/>
+                    <a:bodyPr wrap="square"/>
                     <a:lstStyle/>
                     <a:p>
                       <a:pPr algn="l">
@@ -12624,7 +12624,7 @@
                 </a:tc>
                 <a:tc>
                   <a:txBody>
-                    <a:bodyPr/>
+                    <a:bodyPr wrap="square"/>
                     <a:lstStyle/>
                     <a:p>
                       <a:pPr algn="l">
@@ -12677,7 +12677,7 @@
                 </a:tc>
                 <a:tc>
                   <a:txBody>
-                    <a:bodyPr/>
+                    <a:bodyPr wrap="square"/>
                     <a:lstStyle/>
                     <a:p>
                       <a:pPr algn="r">
@@ -12730,7 +12730,7 @@
                 </a:tc>
                 <a:tc>
                   <a:txBody>
-                    <a:bodyPr/>
+                    <a:bodyPr wrap="square"/>
                     <a:lstStyle/>
                     <a:p>
                       <a:pPr algn="l">
@@ -12782,10 +12782,10 @@
                   </a:tcPr>
                 </a:tc>
               </a:tr>
-              <a:tr h="678484">
-                <a:tc>
-                  <a:txBody>
-                    <a:bodyPr/>
+              <a:tr h="692070">
+                <a:tc>
+                  <a:txBody>
+                    <a:bodyPr wrap="square"/>
                     <a:lstStyle/>
                     <a:p>
                       <a:pPr algn="ctr">
@@ -12838,7 +12838,7 @@
                 </a:tc>
                 <a:tc>
                   <a:txBody>
-                    <a:bodyPr/>
+                    <a:bodyPr wrap="square"/>
                     <a:lstStyle/>
                     <a:p>
                       <a:pPr algn="l">
@@ -12891,7 +12891,7 @@
                 </a:tc>
                 <a:tc>
                   <a:txBody>
-                    <a:bodyPr/>
+                    <a:bodyPr wrap="square"/>
                     <a:lstStyle/>
                     <a:p>
                       <a:pPr algn="l">
@@ -12944,7 +12944,7 @@
                 </a:tc>
                 <a:tc>
                   <a:txBody>
-                    <a:bodyPr/>
+                    <a:bodyPr wrap="square"/>
                     <a:lstStyle/>
                     <a:p>
                       <a:pPr algn="l">
@@ -12997,7 +12997,7 @@
                 </a:tc>
                 <a:tc>
                   <a:txBody>
-                    <a:bodyPr/>
+                    <a:bodyPr wrap="square"/>
                     <a:lstStyle/>
                     <a:p>
                       <a:pPr algn="r">
@@ -13050,7 +13050,7 @@
                 </a:tc>
                 <a:tc>
                   <a:txBody>
-                    <a:bodyPr/>
+                    <a:bodyPr wrap="square"/>
                     <a:lstStyle/>
                     <a:p>
                       <a:pPr algn="l">
@@ -13102,10 +13102,10 @@
                   </a:tcPr>
                 </a:tc>
               </a:tr>
-              <a:tr h="678484">
-                <a:tc>
-                  <a:txBody>
-                    <a:bodyPr/>
+              <a:tr h="692070">
+                <a:tc>
+                  <a:txBody>
+                    <a:bodyPr wrap="square"/>
                     <a:lstStyle/>
                     <a:p>
                       <a:pPr algn="ctr">
@@ -13158,7 +13158,7 @@
                 </a:tc>
                 <a:tc>
                   <a:txBody>
-                    <a:bodyPr/>
+                    <a:bodyPr wrap="square"/>
                     <a:lstStyle/>
                     <a:p>
                       <a:pPr algn="l">
@@ -13211,7 +13211,7 @@
                 </a:tc>
                 <a:tc>
                   <a:txBody>
-                    <a:bodyPr/>
+                    <a:bodyPr wrap="square"/>
                     <a:lstStyle/>
                     <a:p>
                       <a:pPr algn="l">
@@ -13264,7 +13264,7 @@
                 </a:tc>
                 <a:tc>
                   <a:txBody>
-                    <a:bodyPr/>
+                    <a:bodyPr wrap="square"/>
                     <a:lstStyle/>
                     <a:p>
                       <a:pPr algn="l">
@@ -13317,7 +13317,7 @@
                 </a:tc>
                 <a:tc>
                   <a:txBody>
-                    <a:bodyPr/>
+                    <a:bodyPr wrap="square"/>
                     <a:lstStyle/>
                     <a:p>
                       <a:pPr algn="r">
@@ -13370,7 +13370,7 @@
                 </a:tc>
                 <a:tc>
                   <a:txBody>
-                    <a:bodyPr/>
+                    <a:bodyPr wrap="square"/>
                     <a:lstStyle/>
                     <a:p>
                       <a:pPr algn="l">
@@ -13422,10 +13422,10 @@
                   </a:tcPr>
                 </a:tc>
               </a:tr>
-              <a:tr h="678484">
-                <a:tc>
-                  <a:txBody>
-                    <a:bodyPr/>
+              <a:tr h="692070">
+                <a:tc>
+                  <a:txBody>
+                    <a:bodyPr wrap="square"/>
                     <a:lstStyle/>
                     <a:p>
                       <a:pPr algn="ctr">
@@ -13478,7 +13478,7 @@
                 </a:tc>
                 <a:tc>
                   <a:txBody>
-                    <a:bodyPr/>
+                    <a:bodyPr wrap="square"/>
                     <a:lstStyle/>
                     <a:p>
                       <a:pPr algn="l">
@@ -13531,7 +13531,7 @@
                 </a:tc>
                 <a:tc>
                   <a:txBody>
-                    <a:bodyPr/>
+                    <a:bodyPr wrap="square"/>
                     <a:lstStyle/>
                     <a:p>
                       <a:pPr algn="l">
@@ -13584,7 +13584,7 @@
                 </a:tc>
                 <a:tc>
                   <a:txBody>
-                    <a:bodyPr/>
+                    <a:bodyPr wrap="square"/>
                     <a:lstStyle/>
                     <a:p>
                       <a:pPr algn="l">
@@ -13637,7 +13637,7 @@
                 </a:tc>
                 <a:tc>
                   <a:txBody>
-                    <a:bodyPr/>
+                    <a:bodyPr wrap="square"/>
                     <a:lstStyle/>
                     <a:p>
                       <a:pPr algn="r">
@@ -13690,7 +13690,7 @@
                 </a:tc>
                 <a:tc>
                   <a:txBody>
-                    <a:bodyPr/>
+                    <a:bodyPr wrap="square"/>
                     <a:lstStyle/>
                     <a:p>
                       <a:pPr algn="l">
@@ -13833,7 +13833,7 @@
         </p:nvGraphicFramePr>
         <p:xfrm>
           <a:off x="533095" y="1030528"/>
-          <a:ext cx="11415367" cy="5488223"/>
+          <a:ext cx="11415367" cy="5583325"/>
         </p:xfrm>
         <a:graphic>
           <a:graphicData uri="http://schemas.openxmlformats.org/drawingml/2006/table">
@@ -13852,7 +13852,7 @@
               <a:tr h="738835">
                 <a:tc>
                   <a:txBody>
-                    <a:bodyPr/>
+                    <a:bodyPr wrap="square"/>
                     <a:lstStyle/>
                     <a:p>
                       <a:pPr algn="ctr">
@@ -13905,7 +13905,7 @@
                 </a:tc>
                 <a:tc>
                   <a:txBody>
-                    <a:bodyPr/>
+                    <a:bodyPr wrap="square"/>
                     <a:lstStyle/>
                     <a:p>
                       <a:pPr algn="ctr">
@@ -13958,7 +13958,7 @@
                 </a:tc>
                 <a:tc>
                   <a:txBody>
-                    <a:bodyPr/>
+                    <a:bodyPr wrap="square"/>
                     <a:lstStyle/>
                     <a:p>
                       <a:pPr algn="ctr">
@@ -14011,7 +14011,7 @@
                 </a:tc>
                 <a:tc>
                   <a:txBody>
-                    <a:bodyPr/>
+                    <a:bodyPr wrap="square"/>
                     <a:lstStyle/>
                     <a:p>
                       <a:pPr algn="ctr">
@@ -14064,7 +14064,7 @@
                 </a:tc>
                 <a:tc>
                   <a:txBody>
-                    <a:bodyPr/>
+                    <a:bodyPr wrap="square"/>
                     <a:lstStyle/>
                     <a:p>
                       <a:pPr algn="ctr">
@@ -14120,7 +14120,7 @@
                 </a:tc>
                 <a:tc>
                   <a:txBody>
-                    <a:bodyPr/>
+                    <a:bodyPr wrap="square"/>
                     <a:lstStyle/>
                     <a:p>
                       <a:pPr algn="ctr">
@@ -14172,10 +14172,10 @@
                   </a:tcPr>
                 </a:tc>
               </a:tr>
-              <a:tr h="678484">
-                <a:tc>
-                  <a:txBody>
-                    <a:bodyPr/>
+              <a:tr h="692070">
+                <a:tc>
+                  <a:txBody>
+                    <a:bodyPr wrap="square"/>
                     <a:lstStyle/>
                     <a:p>
                       <a:pPr algn="ctr">
@@ -14228,7 +14228,7 @@
                 </a:tc>
                 <a:tc>
                   <a:txBody>
-                    <a:bodyPr/>
+                    <a:bodyPr wrap="square"/>
                     <a:lstStyle/>
                     <a:p>
                       <a:pPr algn="l">
@@ -14281,7 +14281,7 @@
                 </a:tc>
                 <a:tc>
                   <a:txBody>
-                    <a:bodyPr/>
+                    <a:bodyPr wrap="square"/>
                     <a:lstStyle/>
                     <a:p>
                       <a:pPr algn="l">
@@ -14334,7 +14334,7 @@
                 </a:tc>
                 <a:tc>
                   <a:txBody>
-                    <a:bodyPr/>
+                    <a:bodyPr wrap="square"/>
                     <a:lstStyle/>
                     <a:p>
                       <a:pPr algn="l">
@@ -14387,7 +14387,7 @@
                 </a:tc>
                 <a:tc>
                   <a:txBody>
-                    <a:bodyPr/>
+                    <a:bodyPr wrap="square"/>
                     <a:lstStyle/>
                     <a:p>
                       <a:pPr algn="r">
@@ -14440,7 +14440,7 @@
                 </a:tc>
                 <a:tc>
                   <a:txBody>
-                    <a:bodyPr/>
+                    <a:bodyPr wrap="square"/>
                     <a:lstStyle/>
                     <a:p>
                       <a:pPr algn="l">
@@ -14492,10 +14492,10 @@
                   </a:tcPr>
                 </a:tc>
               </a:tr>
-              <a:tr h="678484">
-                <a:tc>
-                  <a:txBody>
-                    <a:bodyPr/>
+              <a:tr h="692070">
+                <a:tc>
+                  <a:txBody>
+                    <a:bodyPr wrap="square"/>
                     <a:lstStyle/>
                     <a:p>
                       <a:pPr algn="ctr">
@@ -14548,7 +14548,7 @@
                 </a:tc>
                 <a:tc>
                   <a:txBody>
-                    <a:bodyPr/>
+                    <a:bodyPr wrap="square"/>
                     <a:lstStyle/>
                     <a:p>
                       <a:pPr algn="l">
@@ -14601,7 +14601,7 @@
                 </a:tc>
                 <a:tc>
                   <a:txBody>
-                    <a:bodyPr/>
+                    <a:bodyPr wrap="square"/>
                     <a:lstStyle/>
                     <a:p>
                       <a:pPr algn="l">
@@ -14654,7 +14654,7 @@
                 </a:tc>
                 <a:tc>
                   <a:txBody>
-                    <a:bodyPr/>
+                    <a:bodyPr wrap="square"/>
                     <a:lstStyle/>
                     <a:p>
                       <a:pPr algn="l">
@@ -14707,7 +14707,7 @@
                 </a:tc>
                 <a:tc>
                   <a:txBody>
-                    <a:bodyPr/>
+                    <a:bodyPr wrap="square"/>
                     <a:lstStyle/>
                     <a:p>
                       <a:pPr algn="r">
@@ -14760,7 +14760,7 @@
                 </a:tc>
                 <a:tc>
                   <a:txBody>
-                    <a:bodyPr/>
+                    <a:bodyPr wrap="square"/>
                     <a:lstStyle/>
                     <a:p>
                       <a:pPr algn="l">
@@ -14812,10 +14812,10 @@
                   </a:tcPr>
                 </a:tc>
               </a:tr>
-              <a:tr h="678484">
-                <a:tc>
-                  <a:txBody>
-                    <a:bodyPr/>
+              <a:tr h="692070">
+                <a:tc>
+                  <a:txBody>
+                    <a:bodyPr wrap="square"/>
                     <a:lstStyle/>
                     <a:p>
                       <a:pPr algn="ctr">
@@ -14868,7 +14868,7 @@
                 </a:tc>
                 <a:tc>
                   <a:txBody>
-                    <a:bodyPr/>
+                    <a:bodyPr wrap="square"/>
                     <a:lstStyle/>
                     <a:p>
                       <a:pPr algn="l">
@@ -14921,7 +14921,7 @@
                 </a:tc>
                 <a:tc>
                   <a:txBody>
-                    <a:bodyPr/>
+                    <a:bodyPr wrap="square"/>
                     <a:lstStyle/>
                     <a:p>
                       <a:pPr algn="l">
@@ -14974,7 +14974,7 @@
                 </a:tc>
                 <a:tc>
                   <a:txBody>
-                    <a:bodyPr/>
+                    <a:bodyPr wrap="square"/>
                     <a:lstStyle/>
                     <a:p>
                       <a:pPr algn="l">
@@ -15027,7 +15027,7 @@
                 </a:tc>
                 <a:tc>
                   <a:txBody>
-                    <a:bodyPr/>
+                    <a:bodyPr wrap="square"/>
                     <a:lstStyle/>
                     <a:p>
                       <a:pPr algn="r">
@@ -15080,7 +15080,7 @@
                 </a:tc>
                 <a:tc>
                   <a:txBody>
-                    <a:bodyPr/>
+                    <a:bodyPr wrap="square"/>
                     <a:lstStyle/>
                     <a:p>
                       <a:pPr algn="l">
@@ -15132,10 +15132,10 @@
                   </a:tcPr>
                 </a:tc>
               </a:tr>
-              <a:tr h="678484">
-                <a:tc>
-                  <a:txBody>
-                    <a:bodyPr/>
+              <a:tr h="692070">
+                <a:tc>
+                  <a:txBody>
+                    <a:bodyPr wrap="square"/>
                     <a:lstStyle/>
                     <a:p>
                       <a:pPr algn="ctr">
@@ -15188,7 +15188,7 @@
                 </a:tc>
                 <a:tc>
                   <a:txBody>
-                    <a:bodyPr/>
+                    <a:bodyPr wrap="square"/>
                     <a:lstStyle/>
                     <a:p>
                       <a:pPr algn="l">
@@ -15241,7 +15241,7 @@
                 </a:tc>
                 <a:tc>
                   <a:txBody>
-                    <a:bodyPr/>
+                    <a:bodyPr wrap="square"/>
                     <a:lstStyle/>
                     <a:p>
                       <a:pPr algn="l">
@@ -15294,7 +15294,7 @@
                 </a:tc>
                 <a:tc>
                   <a:txBody>
-                    <a:bodyPr/>
+                    <a:bodyPr wrap="square"/>
                     <a:lstStyle/>
                     <a:p>
                       <a:pPr algn="l">
@@ -15347,7 +15347,7 @@
                 </a:tc>
                 <a:tc>
                   <a:txBody>
-                    <a:bodyPr/>
+                    <a:bodyPr wrap="square"/>
                     <a:lstStyle/>
                     <a:p>
                       <a:pPr algn="r">
@@ -15400,7 +15400,7 @@
                 </a:tc>
                 <a:tc>
                   <a:txBody>
-                    <a:bodyPr/>
+                    <a:bodyPr wrap="square"/>
                     <a:lstStyle/>
                     <a:p>
                       <a:pPr algn="l">
@@ -15452,10 +15452,10 @@
                   </a:tcPr>
                 </a:tc>
               </a:tr>
-              <a:tr h="678484">
-                <a:tc>
-                  <a:txBody>
-                    <a:bodyPr/>
+              <a:tr h="692070">
+                <a:tc>
+                  <a:txBody>
+                    <a:bodyPr wrap="square"/>
                     <a:lstStyle/>
                     <a:p>
                       <a:pPr algn="ctr">
@@ -15508,7 +15508,7 @@
                 </a:tc>
                 <a:tc>
                   <a:txBody>
-                    <a:bodyPr/>
+                    <a:bodyPr wrap="square"/>
                     <a:lstStyle/>
                     <a:p>
                       <a:pPr algn="l">
@@ -15561,7 +15561,7 @@
                 </a:tc>
                 <a:tc>
                   <a:txBody>
-                    <a:bodyPr/>
+                    <a:bodyPr wrap="square"/>
                     <a:lstStyle/>
                     <a:p>
                       <a:pPr algn="l">
@@ -15614,7 +15614,7 @@
                 </a:tc>
                 <a:tc>
                   <a:txBody>
-                    <a:bodyPr/>
+                    <a:bodyPr wrap="square"/>
                     <a:lstStyle/>
                     <a:p>
                       <a:pPr algn="l">
@@ -15667,7 +15667,7 @@
                 </a:tc>
                 <a:tc>
                   <a:txBody>
-                    <a:bodyPr/>
+                    <a:bodyPr wrap="square"/>
                     <a:lstStyle/>
                     <a:p>
                       <a:pPr algn="r">
@@ -15720,7 +15720,7 @@
                 </a:tc>
                 <a:tc>
                   <a:txBody>
-                    <a:bodyPr/>
+                    <a:bodyPr wrap="square"/>
                     <a:lstStyle/>
                     <a:p>
                       <a:pPr algn="l">
@@ -15772,10 +15772,10 @@
                   </a:tcPr>
                 </a:tc>
               </a:tr>
-              <a:tr h="678484">
-                <a:tc>
-                  <a:txBody>
-                    <a:bodyPr/>
+              <a:tr h="692070">
+                <a:tc>
+                  <a:txBody>
+                    <a:bodyPr wrap="square"/>
                     <a:lstStyle/>
                     <a:p>
                       <a:pPr algn="ctr">
@@ -15828,7 +15828,7 @@
                 </a:tc>
                 <a:tc>
                   <a:txBody>
-                    <a:bodyPr/>
+                    <a:bodyPr wrap="square"/>
                     <a:lstStyle/>
                     <a:p>
                       <a:pPr algn="l">
@@ -15881,7 +15881,7 @@
                 </a:tc>
                 <a:tc>
                   <a:txBody>
-                    <a:bodyPr/>
+                    <a:bodyPr wrap="square"/>
                     <a:lstStyle/>
                     <a:p>
                       <a:pPr algn="l">
@@ -15934,7 +15934,7 @@
                 </a:tc>
                 <a:tc>
                   <a:txBody>
-                    <a:bodyPr/>
+                    <a:bodyPr wrap="square"/>
                     <a:lstStyle/>
                     <a:p>
                       <a:pPr algn="l">
@@ -15987,7 +15987,7 @@
                 </a:tc>
                 <a:tc>
                   <a:txBody>
-                    <a:bodyPr/>
+                    <a:bodyPr wrap="square"/>
                     <a:lstStyle/>
                     <a:p>
                       <a:pPr algn="r">
@@ -16040,7 +16040,7 @@
                 </a:tc>
                 <a:tc>
                   <a:txBody>
-                    <a:bodyPr/>
+                    <a:bodyPr wrap="square"/>
                     <a:lstStyle/>
                     <a:p>
                       <a:pPr algn="l">
@@ -16092,10 +16092,10 @@
                   </a:tcPr>
                 </a:tc>
               </a:tr>
-              <a:tr h="678484">
-                <a:tc>
-                  <a:txBody>
-                    <a:bodyPr/>
+              <a:tr h="692070">
+                <a:tc>
+                  <a:txBody>
+                    <a:bodyPr wrap="square"/>
                     <a:lstStyle/>
                     <a:p>
                       <a:pPr algn="ctr">
@@ -16148,7 +16148,7 @@
                 </a:tc>
                 <a:tc>
                   <a:txBody>
-                    <a:bodyPr/>
+                    <a:bodyPr wrap="square"/>
                     <a:lstStyle/>
                     <a:p>
                       <a:pPr algn="l">
@@ -16201,7 +16201,7 @@
                 </a:tc>
                 <a:tc>
                   <a:txBody>
-                    <a:bodyPr/>
+                    <a:bodyPr wrap="square"/>
                     <a:lstStyle/>
                     <a:p>
                       <a:pPr algn="l">
@@ -16254,7 +16254,7 @@
                 </a:tc>
                 <a:tc>
                   <a:txBody>
-                    <a:bodyPr/>
+                    <a:bodyPr wrap="square"/>
                     <a:lstStyle/>
                     <a:p>
                       <a:pPr algn="l">
@@ -16307,7 +16307,7 @@
                 </a:tc>
                 <a:tc>
                   <a:txBody>
-                    <a:bodyPr/>
+                    <a:bodyPr wrap="square"/>
                     <a:lstStyle/>
                     <a:p>
                       <a:pPr algn="r">
@@ -16360,7 +16360,7 @@
                 </a:tc>
                 <a:tc>
                   <a:txBody>
-                    <a:bodyPr/>
+                    <a:bodyPr wrap="square"/>
                     <a:lstStyle/>
                     <a:p>
                       <a:pPr algn="l">
@@ -16503,7 +16503,7 @@
         </p:nvGraphicFramePr>
         <p:xfrm>
           <a:off x="533095" y="1030528"/>
-          <a:ext cx="11415367" cy="4809739"/>
+          <a:ext cx="11415367" cy="4891255"/>
         </p:xfrm>
         <a:graphic>
           <a:graphicData uri="http://schemas.openxmlformats.org/drawingml/2006/table">
@@ -16522,7 +16522,7 @@
               <a:tr h="738835">
                 <a:tc>
                   <a:txBody>
-                    <a:bodyPr/>
+                    <a:bodyPr wrap="square"/>
                     <a:lstStyle/>
                     <a:p>
                       <a:pPr algn="ctr">
@@ -16575,7 +16575,7 @@
                 </a:tc>
                 <a:tc>
                   <a:txBody>
-                    <a:bodyPr/>
+                    <a:bodyPr wrap="square"/>
                     <a:lstStyle/>
                     <a:p>
                       <a:pPr algn="ctr">
@@ -16628,7 +16628,7 @@
                 </a:tc>
                 <a:tc>
                   <a:txBody>
-                    <a:bodyPr/>
+                    <a:bodyPr wrap="square"/>
                     <a:lstStyle/>
                     <a:p>
                       <a:pPr algn="ctr">
@@ -16681,7 +16681,7 @@
                 </a:tc>
                 <a:tc>
                   <a:txBody>
-                    <a:bodyPr/>
+                    <a:bodyPr wrap="square"/>
                     <a:lstStyle/>
                     <a:p>
                       <a:pPr algn="ctr">
@@ -16734,7 +16734,7 @@
                 </a:tc>
                 <a:tc>
                   <a:txBody>
-                    <a:bodyPr/>
+                    <a:bodyPr wrap="square"/>
                     <a:lstStyle/>
                     <a:p>
                       <a:pPr algn="ctr">
@@ -16790,7 +16790,7 @@
                 </a:tc>
                 <a:tc>
                   <a:txBody>
-                    <a:bodyPr/>
+                    <a:bodyPr wrap="square"/>
                     <a:lstStyle/>
                     <a:p>
                       <a:pPr algn="ctr">
@@ -16842,10 +16842,10 @@
                   </a:tcPr>
                 </a:tc>
               </a:tr>
-              <a:tr h="678484">
-                <a:tc>
-                  <a:txBody>
-                    <a:bodyPr/>
+              <a:tr h="692070">
+                <a:tc>
+                  <a:txBody>
+                    <a:bodyPr wrap="square"/>
                     <a:lstStyle/>
                     <a:p>
                       <a:pPr algn="ctr">
@@ -16898,7 +16898,7 @@
                 </a:tc>
                 <a:tc>
                   <a:txBody>
-                    <a:bodyPr/>
+                    <a:bodyPr wrap="square"/>
                     <a:lstStyle/>
                     <a:p>
                       <a:pPr algn="l">
@@ -16951,7 +16951,7 @@
                 </a:tc>
                 <a:tc>
                   <a:txBody>
-                    <a:bodyPr/>
+                    <a:bodyPr wrap="square"/>
                     <a:lstStyle/>
                     <a:p>
                       <a:pPr algn="l">
@@ -17004,7 +17004,7 @@
                 </a:tc>
                 <a:tc>
                   <a:txBody>
-                    <a:bodyPr/>
+                    <a:bodyPr wrap="square"/>
                     <a:lstStyle/>
                     <a:p>
                       <a:pPr algn="l">
@@ -17057,7 +17057,7 @@
                 </a:tc>
                 <a:tc>
                   <a:txBody>
-                    <a:bodyPr/>
+                    <a:bodyPr wrap="square"/>
                     <a:lstStyle/>
                     <a:p>
                       <a:pPr algn="r">
@@ -17110,7 +17110,7 @@
                 </a:tc>
                 <a:tc>
                   <a:txBody>
-                    <a:bodyPr/>
+                    <a:bodyPr wrap="square"/>
                     <a:lstStyle/>
                     <a:p>
                       <a:pPr algn="l">
@@ -17162,10 +17162,10 @@
                   </a:tcPr>
                 </a:tc>
               </a:tr>
-              <a:tr h="678484">
-                <a:tc>
-                  <a:txBody>
-                    <a:bodyPr/>
+              <a:tr h="692070">
+                <a:tc>
+                  <a:txBody>
+                    <a:bodyPr wrap="square"/>
                     <a:lstStyle/>
                     <a:p>
                       <a:pPr algn="ctr">
@@ -17218,7 +17218,7 @@
                 </a:tc>
                 <a:tc>
                   <a:txBody>
-                    <a:bodyPr/>
+                    <a:bodyPr wrap="square"/>
                     <a:lstStyle/>
                     <a:p>
                       <a:pPr algn="l">
@@ -17271,7 +17271,7 @@
                 </a:tc>
                 <a:tc>
                   <a:txBody>
-                    <a:bodyPr/>
+                    <a:bodyPr wrap="square"/>
                     <a:lstStyle/>
                     <a:p>
                       <a:pPr algn="l">
@@ -17324,7 +17324,7 @@
                 </a:tc>
                 <a:tc>
                   <a:txBody>
-                    <a:bodyPr/>
+                    <a:bodyPr wrap="square"/>
                     <a:lstStyle/>
                     <a:p>
                       <a:pPr algn="l">
@@ -17377,7 +17377,7 @@
                 </a:tc>
                 <a:tc>
                   <a:txBody>
-                    <a:bodyPr/>
+                    <a:bodyPr wrap="square"/>
                     <a:lstStyle/>
                     <a:p>
                       <a:pPr algn="r">
@@ -17430,7 +17430,7 @@
                 </a:tc>
                 <a:tc>
                   <a:txBody>
-                    <a:bodyPr/>
+                    <a:bodyPr wrap="square"/>
                     <a:lstStyle/>
                     <a:p>
                       <a:pPr algn="l">
@@ -17482,10 +17482,10 @@
                   </a:tcPr>
                 </a:tc>
               </a:tr>
-              <a:tr h="678484">
-                <a:tc>
-                  <a:txBody>
-                    <a:bodyPr/>
+              <a:tr h="692070">
+                <a:tc>
+                  <a:txBody>
+                    <a:bodyPr wrap="square"/>
                     <a:lstStyle/>
                     <a:p>
                       <a:pPr algn="ctr">
@@ -17538,7 +17538,7 @@
                 </a:tc>
                 <a:tc>
                   <a:txBody>
-                    <a:bodyPr/>
+                    <a:bodyPr wrap="square"/>
                     <a:lstStyle/>
                     <a:p>
                       <a:pPr algn="l">
@@ -17591,7 +17591,7 @@
                 </a:tc>
                 <a:tc>
                   <a:txBody>
-                    <a:bodyPr/>
+                    <a:bodyPr wrap="square"/>
                     <a:lstStyle/>
                     <a:p>
                       <a:pPr algn="l">
@@ -17644,7 +17644,7 @@
                 </a:tc>
                 <a:tc>
                   <a:txBody>
-                    <a:bodyPr/>
+                    <a:bodyPr wrap="square"/>
                     <a:lstStyle/>
                     <a:p>
                       <a:pPr algn="l">
@@ -17697,7 +17697,7 @@
                 </a:tc>
                 <a:tc>
                   <a:txBody>
-                    <a:bodyPr/>
+                    <a:bodyPr wrap="square"/>
                     <a:lstStyle/>
                     <a:p>
                       <a:pPr algn="r">
@@ -17750,7 +17750,7 @@
                 </a:tc>
                 <a:tc>
                   <a:txBody>
-                    <a:bodyPr/>
+                    <a:bodyPr wrap="square"/>
                     <a:lstStyle/>
                     <a:p>
                       <a:pPr algn="l">
@@ -17802,10 +17802,10 @@
                   </a:tcPr>
                 </a:tc>
               </a:tr>
-              <a:tr h="678484">
-                <a:tc>
-                  <a:txBody>
-                    <a:bodyPr/>
+              <a:tr h="692070">
+                <a:tc>
+                  <a:txBody>
+                    <a:bodyPr wrap="square"/>
                     <a:lstStyle/>
                     <a:p>
                       <a:pPr algn="ctr">
@@ -17858,7 +17858,7 @@
                 </a:tc>
                 <a:tc>
                   <a:txBody>
-                    <a:bodyPr/>
+                    <a:bodyPr wrap="square"/>
                     <a:lstStyle/>
                     <a:p>
                       <a:pPr algn="l">
@@ -17911,7 +17911,7 @@
                 </a:tc>
                 <a:tc>
                   <a:txBody>
-                    <a:bodyPr/>
+                    <a:bodyPr wrap="square"/>
                     <a:lstStyle/>
                     <a:p>
                       <a:pPr algn="l">
@@ -17964,7 +17964,7 @@
                 </a:tc>
                 <a:tc>
                   <a:txBody>
-                    <a:bodyPr/>
+                    <a:bodyPr wrap="square"/>
                     <a:lstStyle/>
                     <a:p>
                       <a:pPr algn="l">
@@ -18017,7 +18017,7 @@
                 </a:tc>
                 <a:tc>
                   <a:txBody>
-                    <a:bodyPr/>
+                    <a:bodyPr wrap="square"/>
                     <a:lstStyle/>
                     <a:p>
                       <a:pPr algn="r">
@@ -18070,7 +18070,7 @@
                 </a:tc>
                 <a:tc>
                   <a:txBody>
-                    <a:bodyPr/>
+                    <a:bodyPr wrap="square"/>
                     <a:lstStyle/>
                     <a:p>
                       <a:pPr algn="l">
@@ -18122,10 +18122,10 @@
                   </a:tcPr>
                 </a:tc>
               </a:tr>
-              <a:tr h="678484">
-                <a:tc>
-                  <a:txBody>
-                    <a:bodyPr/>
+              <a:tr h="692070">
+                <a:tc>
+                  <a:txBody>
+                    <a:bodyPr wrap="square"/>
                     <a:lstStyle/>
                     <a:p>
                       <a:pPr algn="ctr">
@@ -18178,7 +18178,7 @@
                 </a:tc>
                 <a:tc>
                   <a:txBody>
-                    <a:bodyPr/>
+                    <a:bodyPr wrap="square"/>
                     <a:lstStyle/>
                     <a:p>
                       <a:pPr algn="l">
@@ -18231,7 +18231,7 @@
                 </a:tc>
                 <a:tc>
                   <a:txBody>
-                    <a:bodyPr/>
+                    <a:bodyPr wrap="square"/>
                     <a:lstStyle/>
                     <a:p>
                       <a:pPr algn="l">
@@ -18284,7 +18284,7 @@
                 </a:tc>
                 <a:tc>
                   <a:txBody>
-                    <a:bodyPr/>
+                    <a:bodyPr wrap="square"/>
                     <a:lstStyle/>
                     <a:p>
                       <a:pPr algn="l">
@@ -18337,7 +18337,7 @@
                 </a:tc>
                 <a:tc>
                   <a:txBody>
-                    <a:bodyPr/>
+                    <a:bodyPr wrap="square"/>
                     <a:lstStyle/>
                     <a:p>
                       <a:pPr algn="r">
@@ -18381,7 +18381,7 @@
                 </a:tc>
                 <a:tc>
                   <a:txBody>
-                    <a:bodyPr/>
+                    <a:bodyPr wrap="square"/>
                     <a:lstStyle/>
                     <a:p>
                       <a:pPr algn="l">
@@ -18433,10 +18433,10 @@
                   </a:tcPr>
                 </a:tc>
               </a:tr>
-              <a:tr h="678484">
-                <a:tc>
-                  <a:txBody>
-                    <a:bodyPr/>
+              <a:tr h="692070">
+                <a:tc>
+                  <a:txBody>
+                    <a:bodyPr wrap="square"/>
                     <a:lstStyle/>
                     <a:p>
                       <a:pPr algn="ctr">
@@ -18489,7 +18489,7 @@
                 </a:tc>
                 <a:tc>
                   <a:txBody>
-                    <a:bodyPr/>
+                    <a:bodyPr wrap="square"/>
                     <a:lstStyle/>
                     <a:p>
                       <a:pPr algn="l">
@@ -18542,7 +18542,7 @@
                 </a:tc>
                 <a:tc>
                   <a:txBody>
-                    <a:bodyPr/>
+                    <a:bodyPr wrap="square"/>
                     <a:lstStyle/>
                     <a:p>
                       <a:pPr algn="l">
@@ -18604,7 +18604,7 @@
                 </a:tc>
                 <a:tc>
                   <a:txBody>
-                    <a:bodyPr/>
+                    <a:bodyPr wrap="square"/>
                     <a:lstStyle/>
                     <a:p>
                       <a:pPr algn="l">
@@ -18648,7 +18648,7 @@
                 </a:tc>
                 <a:tc>
                   <a:txBody>
-                    <a:bodyPr/>
+                    <a:bodyPr wrap="square"/>
                     <a:lstStyle/>
                     <a:p>
                       <a:pPr algn="r">
@@ -18692,7 +18692,7 @@
                 </a:tc>
                 <a:tc>
                   <a:txBody>
-                    <a:bodyPr/>
+                    <a:bodyPr wrap="square"/>
                     <a:lstStyle/>
                     <a:p>
                       <a:pPr algn="l">

</xml_diff>

<commit_message>
Keep natural row heights when a slide has few table rows
Stop stretching rows to fill the slide. Use estimated content height for
each row and size the table to fit its rows.

Co-authored-by: Artem Kostin <kostin.artem@gmail.com>
</commit_message>
<xml_diff>
--- a/Дефекты_и_разработки_по_Пилоту.pptx
+++ b/Дефекты_и_разработки_по_Пилоту.pptx
@@ -3163,7 +3163,7 @@
         </p:nvGraphicFramePr>
         <p:xfrm>
           <a:off x="533095" y="1030528"/>
-          <a:ext cx="11415367" cy="5583325"/>
+          <a:ext cx="11415367" cy="5488223"/>
         </p:xfrm>
         <a:graphic>
           <a:graphicData uri="http://schemas.openxmlformats.org/drawingml/2006/table">
@@ -3502,7 +3502,7 @@
                   </a:tcPr>
                 </a:tc>
               </a:tr>
-              <a:tr h="692070">
+              <a:tr h="678484">
                 <a:tc>
                   <a:txBody>
                     <a:bodyPr wrap="square"/>
@@ -3822,7 +3822,7 @@
                   </a:tcPr>
                 </a:tc>
               </a:tr>
-              <a:tr h="692070">
+              <a:tr h="678484">
                 <a:tc>
                   <a:txBody>
                     <a:bodyPr wrap="square"/>
@@ -4142,7 +4142,7 @@
                   </a:tcPr>
                 </a:tc>
               </a:tr>
-              <a:tr h="692070">
+              <a:tr h="678484">
                 <a:tc>
                   <a:txBody>
                     <a:bodyPr wrap="square"/>
@@ -4462,7 +4462,7 @@
                   </a:tcPr>
                 </a:tc>
               </a:tr>
-              <a:tr h="692070">
+              <a:tr h="678484">
                 <a:tc>
                   <a:txBody>
                     <a:bodyPr wrap="square"/>
@@ -4782,7 +4782,7 @@
                   </a:tcPr>
                 </a:tc>
               </a:tr>
-              <a:tr h="692070">
+              <a:tr h="678484">
                 <a:tc>
                   <a:txBody>
                     <a:bodyPr wrap="square"/>
@@ -5093,7 +5093,7 @@
                   </a:tcPr>
                 </a:tc>
               </a:tr>
-              <a:tr h="692070">
+              <a:tr h="678484">
                 <a:tc>
                   <a:txBody>
                     <a:bodyPr wrap="square"/>
@@ -5413,7 +5413,7 @@
                   </a:tcPr>
                 </a:tc>
               </a:tr>
-              <a:tr h="692070">
+              <a:tr h="678484">
                 <a:tc>
                   <a:txBody>
                     <a:bodyPr wrap="square"/>
@@ -5824,7 +5824,7 @@
         </p:nvGraphicFramePr>
         <p:xfrm>
           <a:off x="533095" y="1030528"/>
-          <a:ext cx="11415367" cy="5583325"/>
+          <a:ext cx="11415367" cy="5488223"/>
         </p:xfrm>
         <a:graphic>
           <a:graphicData uri="http://schemas.openxmlformats.org/drawingml/2006/table">
@@ -6163,7 +6163,7 @@
                   </a:tcPr>
                 </a:tc>
               </a:tr>
-              <a:tr h="692070">
+              <a:tr h="678484">
                 <a:tc>
                   <a:txBody>
                     <a:bodyPr wrap="square"/>
@@ -6483,7 +6483,7 @@
                   </a:tcPr>
                 </a:tc>
               </a:tr>
-              <a:tr h="692070">
+              <a:tr h="678484">
                 <a:tc>
                   <a:txBody>
                     <a:bodyPr wrap="square"/>
@@ -6803,7 +6803,7 @@
                   </a:tcPr>
                 </a:tc>
               </a:tr>
-              <a:tr h="692070">
+              <a:tr h="678484">
                 <a:tc>
                   <a:txBody>
                     <a:bodyPr wrap="square"/>
@@ -7123,7 +7123,7 @@
                   </a:tcPr>
                 </a:tc>
               </a:tr>
-              <a:tr h="692070">
+              <a:tr h="678484">
                 <a:tc>
                   <a:txBody>
                     <a:bodyPr wrap="square"/>
@@ -7443,7 +7443,7 @@
                   </a:tcPr>
                 </a:tc>
               </a:tr>
-              <a:tr h="692070">
+              <a:tr h="678484">
                 <a:tc>
                   <a:txBody>
                     <a:bodyPr wrap="square"/>
@@ -7763,7 +7763,7 @@
                   </a:tcPr>
                 </a:tc>
               </a:tr>
-              <a:tr h="692070">
+              <a:tr h="678484">
                 <a:tc>
                   <a:txBody>
                     <a:bodyPr wrap="square"/>
@@ -8083,7 +8083,7 @@
                   </a:tcPr>
                 </a:tc>
               </a:tr>
-              <a:tr h="692070">
+              <a:tr h="678484">
                 <a:tc>
                   <a:txBody>
                     <a:bodyPr wrap="square"/>
@@ -8494,7 +8494,7 @@
         </p:nvGraphicFramePr>
         <p:xfrm>
           <a:off x="533095" y="1030528"/>
-          <a:ext cx="11415367" cy="5583324"/>
+          <a:ext cx="11415367" cy="5082258"/>
         </p:xfrm>
         <a:graphic>
           <a:graphicData uri="http://schemas.openxmlformats.org/drawingml/2006/table">
@@ -8833,7 +8833,7 @@
                   </a:tcPr>
                 </a:tc>
               </a:tr>
-              <a:tr h="756756">
+              <a:tr h="678484">
                 <a:tc>
                   <a:txBody>
                     <a:bodyPr wrap="square"/>
@@ -9153,7 +9153,7 @@
                   </a:tcPr>
                 </a:tc>
               </a:tr>
-              <a:tr h="756756">
+              <a:tr h="678484">
                 <a:tc>
                   <a:txBody>
                     <a:bodyPr wrap="square"/>
@@ -9473,7 +9473,7 @@
                   </a:tcPr>
                 </a:tc>
               </a:tr>
-              <a:tr h="977533">
+              <a:tr h="876427">
                 <a:tc>
                   <a:txBody>
                     <a:bodyPr wrap="square"/>
@@ -9793,7 +9793,7 @@
                   </a:tcPr>
                 </a:tc>
               </a:tr>
-              <a:tr h="798344">
+              <a:tr h="715772">
                 <a:tc>
                   <a:txBody>
                     <a:bodyPr wrap="square"/>
@@ -10113,7 +10113,7 @@
                   </a:tcPr>
                 </a:tc>
               </a:tr>
-              <a:tr h="756756">
+              <a:tr h="678484">
                 <a:tc>
                   <a:txBody>
                     <a:bodyPr wrap="square"/>
@@ -10433,7 +10433,7 @@
                   </a:tcPr>
                 </a:tc>
               </a:tr>
-              <a:tr h="798344">
+              <a:tr h="715772">
                 <a:tc>
                   <a:txBody>
                     <a:bodyPr wrap="square"/>
@@ -10844,7 +10844,7 @@
         </p:nvGraphicFramePr>
         <p:xfrm>
           <a:off x="533095" y="1030528"/>
-          <a:ext cx="11415367" cy="5583325"/>
+          <a:ext cx="11415367" cy="4921603"/>
         </p:xfrm>
         <a:graphic>
           <a:graphicData uri="http://schemas.openxmlformats.org/drawingml/2006/table">
@@ -11183,7 +11183,7 @@
                   </a:tcPr>
                 </a:tc>
               </a:tr>
-              <a:tr h="829008">
+              <a:tr h="715772">
                 <a:tc>
                   <a:txBody>
                     <a:bodyPr wrap="square"/>
@@ -11503,7 +11503,7 @@
                   </a:tcPr>
                 </a:tc>
               </a:tr>
-              <a:tr h="829008">
+              <a:tr h="715772">
                 <a:tc>
                   <a:txBody>
                     <a:bodyPr wrap="square"/>
@@ -11823,7 +11823,7 @@
                   </a:tcPr>
                 </a:tc>
               </a:tr>
-              <a:tr h="785822">
+              <a:tr h="678484">
                 <a:tc>
                   <a:txBody>
                     <a:bodyPr wrap="square"/>
@@ -12143,7 +12143,7 @@
                   </a:tcPr>
                 </a:tc>
               </a:tr>
-              <a:tr h="785822">
+              <a:tr h="678484">
                 <a:tc>
                   <a:txBody>
                     <a:bodyPr wrap="square"/>
@@ -12454,7 +12454,7 @@
                   </a:tcPr>
                 </a:tc>
               </a:tr>
-              <a:tr h="829008">
+              <a:tr h="715772">
                 <a:tc>
                   <a:txBody>
                     <a:bodyPr wrap="square"/>
@@ -12783,7 +12783,7 @@
                   </a:tcPr>
                 </a:tc>
               </a:tr>
-              <a:tr h="785822">
+              <a:tr h="678484">
                 <a:tc>
                   <a:txBody>
                     <a:bodyPr wrap="square"/>
@@ -13194,7 +13194,7 @@
         </p:nvGraphicFramePr>
         <p:xfrm>
           <a:off x="533095" y="1030528"/>
-          <a:ext cx="11415367" cy="5583324"/>
+          <a:ext cx="11415367" cy="5562799"/>
         </p:xfrm>
         <a:graphic>
           <a:graphicData uri="http://schemas.openxmlformats.org/drawingml/2006/table">
@@ -13533,7 +13533,7 @@
                   </a:tcPr>
                 </a:tc>
               </a:tr>
-              <a:tr h="681371">
+              <a:tr h="678484">
                 <a:tc>
                   <a:txBody>
                     <a:bodyPr wrap="square"/>
@@ -13853,7 +13853,7 @@
                   </a:tcPr>
                 </a:tc>
               </a:tr>
-              <a:tr h="718817">
+              <a:tr h="715772">
                 <a:tc>
                   <a:txBody>
                     <a:bodyPr wrap="square"/>
@@ -14173,7 +14173,7 @@
                   </a:tcPr>
                 </a:tc>
               </a:tr>
-              <a:tr h="681371">
+              <a:tr h="678484">
                 <a:tc>
                   <a:txBody>
                     <a:bodyPr wrap="square"/>
@@ -14493,7 +14493,7 @@
                   </a:tcPr>
                 </a:tc>
               </a:tr>
-              <a:tr h="681371">
+              <a:tr h="678484">
                 <a:tc>
                   <a:txBody>
                     <a:bodyPr wrap="square"/>
@@ -14813,7 +14813,7 @@
                   </a:tcPr>
                 </a:tc>
               </a:tr>
-              <a:tr h="681371">
+              <a:tr h="678484">
                 <a:tc>
                   <a:txBody>
                     <a:bodyPr wrap="square"/>
@@ -15133,7 +15133,7 @@
                   </a:tcPr>
                 </a:tc>
               </a:tr>
-              <a:tr h="681371">
+              <a:tr h="678484">
                 <a:tc>
                   <a:txBody>
                     <a:bodyPr wrap="square"/>
@@ -15453,7 +15453,7 @@
                   </a:tcPr>
                 </a:tc>
               </a:tr>
-              <a:tr h="718817">
+              <a:tr h="715772">
                 <a:tc>
                   <a:txBody>
                     <a:bodyPr wrap="square"/>
@@ -15864,7 +15864,7 @@
         </p:nvGraphicFramePr>
         <p:xfrm>
           <a:off x="533095" y="1030528"/>
-          <a:ext cx="11415367" cy="5583324"/>
+          <a:ext cx="11415367" cy="5205625"/>
         </p:xfrm>
         <a:graphic>
           <a:graphicData uri="http://schemas.openxmlformats.org/drawingml/2006/table">
@@ -16203,7 +16203,7 @@
                   </a:tcPr>
                 </a:tc>
               </a:tr>
-              <a:tr h="735855">
+              <a:tr h="678484">
                 <a:tc>
                   <a:txBody>
                     <a:bodyPr wrap="square"/>
@@ -16523,7 +16523,7 @@
                   </a:tcPr>
                 </a:tc>
               </a:tr>
-              <a:tr h="735855">
+              <a:tr h="678484">
                 <a:tc>
                   <a:txBody>
                     <a:bodyPr wrap="square"/>
@@ -16843,7 +16843,7 @@
                   </a:tcPr>
                 </a:tc>
               </a:tr>
-              <a:tr h="1124774">
+              <a:tr h="1037082">
                 <a:tc>
                   <a:txBody>
                     <a:bodyPr wrap="square"/>
@@ -17163,7 +17163,7 @@
                   </a:tcPr>
                 </a:tc>
               </a:tr>
-              <a:tr h="776295">
+              <a:tr h="715772">
                 <a:tc>
                   <a:txBody>
                     <a:bodyPr wrap="square"/>
@@ -17483,7 +17483,7 @@
                   </a:tcPr>
                 </a:tc>
               </a:tr>
-              <a:tr h="735855">
+              <a:tr h="678484">
                 <a:tc>
                   <a:txBody>
                     <a:bodyPr wrap="square"/>
@@ -17803,7 +17803,7 @@
                   </a:tcPr>
                 </a:tc>
               </a:tr>
-              <a:tr h="735855">
+              <a:tr h="678484">
                 <a:tc>
                   <a:txBody>
                     <a:bodyPr wrap="square"/>
@@ -18214,7 +18214,7 @@
         </p:nvGraphicFramePr>
         <p:xfrm>
           <a:off x="533095" y="1030528"/>
-          <a:ext cx="11415367" cy="5583325"/>
+          <a:ext cx="11415367" cy="2293746"/>
         </p:xfrm>
         <a:graphic>
           <a:graphicData uri="http://schemas.openxmlformats.org/drawingml/2006/table">
@@ -18553,7 +18553,7 @@
                   </a:tcPr>
                 </a:tc>
               </a:tr>
-              <a:tr h="2730600">
+              <a:tr h="876427">
                 <a:tc>
                   <a:txBody>
                     <a:bodyPr wrap="square"/>
@@ -18864,7 +18864,7 @@
                   </a:tcPr>
                 </a:tc>
               </a:tr>
-              <a:tr h="2113890">
+              <a:tr h="678484">
                 <a:tc>
                   <a:txBody>
                     <a:bodyPr wrap="square"/>

</xml_diff>

<commit_message>
Fix key column hyperlinks and rebuild presentation
The pptx in git was generated before hyperlink support, so links were
missing from the committed file. Rebuild the presentation and add
underline styling so keys are visibly clickable.

Co-authored-by: Artem Kostin <kostin.artem@gmail.com>
</commit_message>
<xml_diff>
--- a/Дефекты_и_разработки_по_Пилоту.pptx
+++ b/Дефекты_и_разработки_по_Пилоту.pptx
@@ -3126,7 +3126,7 @@
         </p:nvSpPr>
         <p:spPr>
           <a:xfrm>
-            <a:off x="561441" y="330098"/>
+            <a:off x="533095" y="330098"/>
             <a:ext cx="7772400" cy="411480"/>
           </a:xfrm>
           <a:prstGeom prst="rect">
@@ -3573,11 +3573,12 @@
                         </a:spcAft>
                       </a:pPr>
                       <a:r>
-                        <a:rPr sz="1100" b="0">
+                        <a:rPr sz="1100" b="0" u="sng">
                           <a:solidFill>
                             <a:srgbClr val="77777A"/>
                           </a:solidFill>
                           <a:latin typeface="Calibri"/>
+                          <a:hlinkClick r:id="rId3"/>
                         </a:rPr>
                         <a:t>DEFPROD-6138</a:t>
                       </a:r>
@@ -3893,11 +3894,12 @@
                         </a:spcAft>
                       </a:pPr>
                       <a:r>
-                        <a:rPr sz="1100" b="0">
+                        <a:rPr sz="1100" b="0" u="sng">
                           <a:solidFill>
                             <a:srgbClr val="77777A"/>
                           </a:solidFill>
                           <a:latin typeface="Calibri"/>
+                          <a:hlinkClick r:id="rId4"/>
                         </a:rPr>
                         <a:t>DEFPROD-9222</a:t>
                       </a:r>
@@ -4213,11 +4215,12 @@
                         </a:spcAft>
                       </a:pPr>
                       <a:r>
-                        <a:rPr sz="1100" b="0">
+                        <a:rPr sz="1100" b="0" u="sng">
                           <a:solidFill>
                             <a:srgbClr val="77777A"/>
                           </a:solidFill>
                           <a:latin typeface="Calibri"/>
+                          <a:hlinkClick r:id="rId5"/>
                         </a:rPr>
                         <a:t>DEFPROD-6804</a:t>
                       </a:r>
@@ -4533,11 +4536,12 @@
                         </a:spcAft>
                       </a:pPr>
                       <a:r>
-                        <a:rPr sz="1100" b="0">
+                        <a:rPr sz="1100" b="0" u="sng">
                           <a:solidFill>
                             <a:srgbClr val="77777A"/>
                           </a:solidFill>
                           <a:latin typeface="Calibri"/>
+                          <a:hlinkClick r:id="rId6"/>
                         </a:rPr>
                         <a:t>DEFPROD-10592</a:t>
                       </a:r>
@@ -4853,11 +4857,12 @@
                         </a:spcAft>
                       </a:pPr>
                       <a:r>
-                        <a:rPr sz="1100" b="0">
+                        <a:rPr sz="1100" b="0" u="sng">
                           <a:solidFill>
                             <a:srgbClr val="77777A"/>
                           </a:solidFill>
                           <a:latin typeface="Calibri"/>
+                          <a:hlinkClick r:id="rId7"/>
                         </a:rPr>
                         <a:t>DEFPROD-9603</a:t>
                       </a:r>
@@ -5164,11 +5169,12 @@
                         </a:spcAft>
                       </a:pPr>
                       <a:r>
-                        <a:rPr sz="1100" b="0">
+                        <a:rPr sz="1100" b="0" u="sng">
                           <a:solidFill>
                             <a:srgbClr val="77777A"/>
                           </a:solidFill>
                           <a:latin typeface="Calibri"/>
+                          <a:hlinkClick r:id="rId8"/>
                         </a:rPr>
                         <a:t>DEFPROD-10301</a:t>
                       </a:r>
@@ -5484,11 +5490,12 @@
                         </a:spcAft>
                       </a:pPr>
                       <a:r>
-                        <a:rPr sz="1100" b="0">
+                        <a:rPr sz="1100" b="0" u="sng">
                           <a:solidFill>
                             <a:srgbClr val="77777A"/>
                           </a:solidFill>
                           <a:latin typeface="Calibri"/>
+                          <a:hlinkClick r:id="rId9"/>
                         </a:rPr>
                         <a:t>FTR-7065</a:t>
                       </a:r>
@@ -5787,7 +5794,7 @@
         </p:nvSpPr>
         <p:spPr>
           <a:xfrm>
-            <a:off x="561441" y="330098"/>
+            <a:off x="533095" y="330098"/>
             <a:ext cx="7772400" cy="411480"/>
           </a:xfrm>
           <a:prstGeom prst="rect">
@@ -6234,11 +6241,12 @@
                         </a:spcAft>
                       </a:pPr>
                       <a:r>
-                        <a:rPr sz="1100" b="0">
+                        <a:rPr sz="1100" b="0" u="sng">
                           <a:solidFill>
                             <a:srgbClr val="77777A"/>
                           </a:solidFill>
                           <a:latin typeface="Calibri"/>
+                          <a:hlinkClick r:id="rId3"/>
                         </a:rPr>
                         <a:t>FTR-7063</a:t>
                       </a:r>
@@ -6554,11 +6562,12 @@
                         </a:spcAft>
                       </a:pPr>
                       <a:r>
-                        <a:rPr sz="1100" b="0">
+                        <a:rPr sz="1100" b="0" u="sng">
                           <a:solidFill>
                             <a:srgbClr val="77777A"/>
                           </a:solidFill>
                           <a:latin typeface="Calibri"/>
+                          <a:hlinkClick r:id="rId4"/>
                         </a:rPr>
                         <a:t>FTR-7577</a:t>
                       </a:r>
@@ -6874,11 +6883,12 @@
                         </a:spcAft>
                       </a:pPr>
                       <a:r>
-                        <a:rPr sz="1100" b="0">
+                        <a:rPr sz="1100" b="0" u="sng">
                           <a:solidFill>
                             <a:srgbClr val="77777A"/>
                           </a:solidFill>
                           <a:latin typeface="Calibri"/>
+                          <a:hlinkClick r:id="rId5"/>
                         </a:rPr>
                         <a:t>FTR-7074</a:t>
                       </a:r>
@@ -7194,11 +7204,12 @@
                         </a:spcAft>
                       </a:pPr>
                       <a:r>
-                        <a:rPr sz="1100" b="0">
+                        <a:rPr sz="1100" b="0" u="sng">
                           <a:solidFill>
                             <a:srgbClr val="77777A"/>
                           </a:solidFill>
                           <a:latin typeface="Calibri"/>
+                          <a:hlinkClick r:id="rId6"/>
                         </a:rPr>
                         <a:t>FTR-7057</a:t>
                       </a:r>
@@ -7514,11 +7525,12 @@
                         </a:spcAft>
                       </a:pPr>
                       <a:r>
-                        <a:rPr sz="1100" b="0">
+                        <a:rPr sz="1100" b="0" u="sng">
                           <a:solidFill>
                             <a:srgbClr val="77777A"/>
                           </a:solidFill>
                           <a:latin typeface="Calibri"/>
+                          <a:hlinkClick r:id="rId7"/>
                         </a:rPr>
                         <a:t>FTR-7072</a:t>
                       </a:r>
@@ -7834,11 +7846,12 @@
                         </a:spcAft>
                       </a:pPr>
                       <a:r>
-                        <a:rPr sz="1100" b="0">
+                        <a:rPr sz="1100" b="0" u="sng">
                           <a:solidFill>
                             <a:srgbClr val="77777A"/>
                           </a:solidFill>
                           <a:latin typeface="Calibri"/>
+                          <a:hlinkClick r:id="rId8"/>
                         </a:rPr>
                         <a:t>FTR-7126</a:t>
                       </a:r>
@@ -8154,11 +8167,12 @@
                         </a:spcAft>
                       </a:pPr>
                       <a:r>
-                        <a:rPr sz="1100" b="0">
+                        <a:rPr sz="1100" b="0" u="sng">
                           <a:solidFill>
                             <a:srgbClr val="77777A"/>
                           </a:solidFill>
                           <a:latin typeface="Calibri"/>
+                          <a:hlinkClick r:id="rId9"/>
                         </a:rPr>
                         <a:t>FTR-7110</a:t>
                       </a:r>
@@ -8457,7 +8471,7 @@
         </p:nvSpPr>
         <p:spPr>
           <a:xfrm>
-            <a:off x="561441" y="330098"/>
+            <a:off x="533095" y="330098"/>
             <a:ext cx="7772400" cy="411480"/>
           </a:xfrm>
           <a:prstGeom prst="rect">
@@ -8904,11 +8918,12 @@
                         </a:spcAft>
                       </a:pPr>
                       <a:r>
-                        <a:rPr sz="1100" b="0">
+                        <a:rPr sz="1100" b="0" u="sng">
                           <a:solidFill>
                             <a:srgbClr val="77777A"/>
                           </a:solidFill>
                           <a:latin typeface="Calibri"/>
+                          <a:hlinkClick r:id="rId3"/>
                         </a:rPr>
                         <a:t>FTR-7099</a:t>
                       </a:r>
@@ -9224,11 +9239,12 @@
                         </a:spcAft>
                       </a:pPr>
                       <a:r>
-                        <a:rPr sz="1100" b="0">
+                        <a:rPr sz="1100" b="0" u="sng">
                           <a:solidFill>
                             <a:srgbClr val="77777A"/>
                           </a:solidFill>
                           <a:latin typeface="Calibri"/>
+                          <a:hlinkClick r:id="rId4"/>
                         </a:rPr>
                         <a:t>DEFPROD-7954</a:t>
                       </a:r>
@@ -9544,11 +9560,12 @@
                         </a:spcAft>
                       </a:pPr>
                       <a:r>
-                        <a:rPr sz="1100" b="0">
+                        <a:rPr sz="1100" b="0" u="sng">
                           <a:solidFill>
                             <a:srgbClr val="77777A"/>
                           </a:solidFill>
                           <a:latin typeface="Calibri"/>
+                          <a:hlinkClick r:id="rId5"/>
                         </a:rPr>
                         <a:t>DEFPROD-9229</a:t>
                       </a:r>
@@ -9864,11 +9881,12 @@
                         </a:spcAft>
                       </a:pPr>
                       <a:r>
-                        <a:rPr sz="1100" b="0">
+                        <a:rPr sz="1100" b="0" u="sng">
                           <a:solidFill>
                             <a:srgbClr val="77777A"/>
                           </a:solidFill>
                           <a:latin typeface="Calibri"/>
+                          <a:hlinkClick r:id="rId6"/>
                         </a:rPr>
                         <a:t>DEFPROD-9289</a:t>
                       </a:r>
@@ -10184,11 +10202,12 @@
                         </a:spcAft>
                       </a:pPr>
                       <a:r>
-                        <a:rPr sz="1100" b="0">
+                        <a:rPr sz="1100" b="0" u="sng">
                           <a:solidFill>
                             <a:srgbClr val="77777A"/>
                           </a:solidFill>
                           <a:latin typeface="Calibri"/>
+                          <a:hlinkClick r:id="rId7"/>
                         </a:rPr>
                         <a:t>DEFPROD-9430</a:t>
                       </a:r>
@@ -10504,11 +10523,12 @@
                         </a:spcAft>
                       </a:pPr>
                       <a:r>
-                        <a:rPr sz="1100" b="0">
+                        <a:rPr sz="1100" b="0" u="sng">
                           <a:solidFill>
                             <a:srgbClr val="77777A"/>
                           </a:solidFill>
                           <a:latin typeface="Calibri"/>
+                          <a:hlinkClick r:id="rId8"/>
                         </a:rPr>
                         <a:t>DEFPROD-9604</a:t>
                       </a:r>
@@ -10807,7 +10827,7 @@
         </p:nvSpPr>
         <p:spPr>
           <a:xfrm>
-            <a:off x="561441" y="330098"/>
+            <a:off x="533095" y="330098"/>
             <a:ext cx="7772400" cy="411480"/>
           </a:xfrm>
           <a:prstGeom prst="rect">
@@ -11254,11 +11274,12 @@
                         </a:spcAft>
                       </a:pPr>
                       <a:r>
-                        <a:rPr sz="1100" b="0">
+                        <a:rPr sz="1100" b="0" u="sng">
                           <a:solidFill>
                             <a:srgbClr val="77777A"/>
                           </a:solidFill>
                           <a:latin typeface="Calibri"/>
+                          <a:hlinkClick r:id="rId3"/>
                         </a:rPr>
                         <a:t>DEFPROD-4335</a:t>
                       </a:r>
@@ -11574,11 +11595,12 @@
                         </a:spcAft>
                       </a:pPr>
                       <a:r>
-                        <a:rPr sz="1100" b="0">
+                        <a:rPr sz="1100" b="0" u="sng">
                           <a:solidFill>
                             <a:srgbClr val="77777A"/>
                           </a:solidFill>
                           <a:latin typeface="Calibri"/>
+                          <a:hlinkClick r:id="rId4"/>
                         </a:rPr>
                         <a:t>DEFPROD-4462</a:t>
                       </a:r>
@@ -11894,11 +11916,12 @@
                         </a:spcAft>
                       </a:pPr>
                       <a:r>
-                        <a:rPr sz="1100" b="0">
+                        <a:rPr sz="1100" b="0" u="sng">
                           <a:solidFill>
                             <a:srgbClr val="77777A"/>
                           </a:solidFill>
                           <a:latin typeface="Calibri"/>
+                          <a:hlinkClick r:id="rId5"/>
                         </a:rPr>
                         <a:t>DEFPROD-4686</a:t>
                       </a:r>
@@ -12214,11 +12237,12 @@
                         </a:spcAft>
                       </a:pPr>
                       <a:r>
-                        <a:rPr sz="1100" b="0">
+                        <a:rPr sz="1100" b="0" u="sng">
                           <a:solidFill>
                             <a:srgbClr val="77777A"/>
                           </a:solidFill>
                           <a:latin typeface="Calibri"/>
+                          <a:hlinkClick r:id="rId6"/>
                         </a:rPr>
                         <a:t>DEFPROD-5641</a:t>
                       </a:r>
@@ -12525,11 +12549,12 @@
                         </a:spcAft>
                       </a:pPr>
                       <a:r>
-                        <a:rPr sz="1100" b="0">
+                        <a:rPr sz="1100" b="0" u="sng">
                           <a:solidFill>
                             <a:srgbClr val="77777A"/>
                           </a:solidFill>
                           <a:latin typeface="Calibri"/>
+                          <a:hlinkClick r:id="rId7"/>
                         </a:rPr>
                         <a:t>DEFPROD-6026</a:t>
                       </a:r>
@@ -12854,11 +12879,12 @@
                         </a:spcAft>
                       </a:pPr>
                       <a:r>
-                        <a:rPr sz="1100" b="0">
+                        <a:rPr sz="1100" b="0" u="sng">
                           <a:solidFill>
                             <a:srgbClr val="77777A"/>
                           </a:solidFill>
                           <a:latin typeface="Calibri"/>
+                          <a:hlinkClick r:id="rId8"/>
                         </a:rPr>
                         <a:t>DEFPROD-6290</a:t>
                       </a:r>
@@ -13157,7 +13183,7 @@
         </p:nvSpPr>
         <p:spPr>
           <a:xfrm>
-            <a:off x="561441" y="330098"/>
+            <a:off x="533095" y="330098"/>
             <a:ext cx="7772400" cy="411480"/>
           </a:xfrm>
           <a:prstGeom prst="rect">
@@ -13604,11 +13630,12 @@
                         </a:spcAft>
                       </a:pPr>
                       <a:r>
-                        <a:rPr sz="1100" b="0">
+                        <a:rPr sz="1100" b="0" u="sng">
                           <a:solidFill>
                             <a:srgbClr val="77777A"/>
                           </a:solidFill>
                           <a:latin typeface="Calibri"/>
+                          <a:hlinkClick r:id="rId3"/>
                         </a:rPr>
                         <a:t>DEFPROD-6703</a:t>
                       </a:r>
@@ -13924,11 +13951,12 @@
                         </a:spcAft>
                       </a:pPr>
                       <a:r>
-                        <a:rPr sz="1100" b="0">
+                        <a:rPr sz="1100" b="0" u="sng">
                           <a:solidFill>
                             <a:srgbClr val="77777A"/>
                           </a:solidFill>
                           <a:latin typeface="Calibri"/>
+                          <a:hlinkClick r:id="rId4"/>
                         </a:rPr>
                         <a:t>DEFPROD-7774</a:t>
                       </a:r>
@@ -14244,11 +14272,12 @@
                         </a:spcAft>
                       </a:pPr>
                       <a:r>
-                        <a:rPr sz="1100" b="0">
+                        <a:rPr sz="1100" b="0" u="sng">
                           <a:solidFill>
                             <a:srgbClr val="77777A"/>
                           </a:solidFill>
                           <a:latin typeface="Calibri"/>
+                          <a:hlinkClick r:id="rId5"/>
                         </a:rPr>
                         <a:t>DEFPROD-9034</a:t>
                       </a:r>
@@ -14564,11 +14593,12 @@
                         </a:spcAft>
                       </a:pPr>
                       <a:r>
-                        <a:rPr sz="1100" b="0">
+                        <a:rPr sz="1100" b="0" u="sng">
                           <a:solidFill>
                             <a:srgbClr val="77777A"/>
                           </a:solidFill>
                           <a:latin typeface="Calibri"/>
+                          <a:hlinkClick r:id="rId6"/>
                         </a:rPr>
                         <a:t>DEFPROD-9797</a:t>
                       </a:r>
@@ -14884,11 +14914,12 @@
                         </a:spcAft>
                       </a:pPr>
                       <a:r>
-                        <a:rPr sz="1100" b="0">
+                        <a:rPr sz="1100" b="0" u="sng">
                           <a:solidFill>
                             <a:srgbClr val="77777A"/>
                           </a:solidFill>
                           <a:latin typeface="Calibri"/>
+                          <a:hlinkClick r:id="rId7"/>
                         </a:rPr>
                         <a:t>DEFPROD-9845</a:t>
                       </a:r>
@@ -15204,11 +15235,12 @@
                         </a:spcAft>
                       </a:pPr>
                       <a:r>
-                        <a:rPr sz="1100" b="0">
+                        <a:rPr sz="1100" b="0" u="sng">
                           <a:solidFill>
                             <a:srgbClr val="77777A"/>
                           </a:solidFill>
                           <a:latin typeface="Calibri"/>
+                          <a:hlinkClick r:id="rId8"/>
                         </a:rPr>
                         <a:t>DEFPROD-10152</a:t>
                       </a:r>
@@ -15524,11 +15556,12 @@
                         </a:spcAft>
                       </a:pPr>
                       <a:r>
-                        <a:rPr sz="1100" b="0">
+                        <a:rPr sz="1100" b="0" u="sng">
                           <a:solidFill>
                             <a:srgbClr val="77777A"/>
                           </a:solidFill>
                           <a:latin typeface="Calibri"/>
+                          <a:hlinkClick r:id="rId9"/>
                         </a:rPr>
                         <a:t>DEFPROD-10281</a:t>
                       </a:r>
@@ -15827,7 +15860,7 @@
         </p:nvSpPr>
         <p:spPr>
           <a:xfrm>
-            <a:off x="561441" y="330098"/>
+            <a:off x="533095" y="330098"/>
             <a:ext cx="7772400" cy="411480"/>
           </a:xfrm>
           <a:prstGeom prst="rect">
@@ -16274,11 +16307,12 @@
                         </a:spcAft>
                       </a:pPr>
                       <a:r>
-                        <a:rPr sz="1100" b="0">
+                        <a:rPr sz="1100" b="0" u="sng">
                           <a:solidFill>
                             <a:srgbClr val="77777A"/>
                           </a:solidFill>
                           <a:latin typeface="Calibri"/>
+                          <a:hlinkClick r:id="rId3"/>
                         </a:rPr>
                         <a:t>DEFPROD-10282</a:t>
                       </a:r>
@@ -16594,11 +16628,12 @@
                         </a:spcAft>
                       </a:pPr>
                       <a:r>
-                        <a:rPr sz="1100" b="0">
+                        <a:rPr sz="1100" b="0" u="sng">
                           <a:solidFill>
                             <a:srgbClr val="77777A"/>
                           </a:solidFill>
                           <a:latin typeface="Calibri"/>
+                          <a:hlinkClick r:id="rId4"/>
                         </a:rPr>
                         <a:t>DEFPROD-10579</a:t>
                       </a:r>
@@ -16914,11 +16949,12 @@
                         </a:spcAft>
                       </a:pPr>
                       <a:r>
-                        <a:rPr sz="1100" b="0">
+                        <a:rPr sz="1100" b="0" u="sng">
                           <a:solidFill>
                             <a:srgbClr val="77777A"/>
                           </a:solidFill>
                           <a:latin typeface="Calibri"/>
+                          <a:hlinkClick r:id="rId5"/>
                         </a:rPr>
                         <a:t>DEFPROD-6889</a:t>
                       </a:r>
@@ -17234,11 +17270,12 @@
                         </a:spcAft>
                       </a:pPr>
                       <a:r>
-                        <a:rPr sz="1100" b="0">
+                        <a:rPr sz="1100" b="0" u="sng">
                           <a:solidFill>
                             <a:srgbClr val="77777A"/>
                           </a:solidFill>
                           <a:latin typeface="Calibri"/>
+                          <a:hlinkClick r:id="rId6"/>
                         </a:rPr>
                         <a:t>DEFPROD-8123</a:t>
                       </a:r>
@@ -17554,11 +17591,12 @@
                         </a:spcAft>
                       </a:pPr>
                       <a:r>
-                        <a:rPr sz="1100" b="0">
+                        <a:rPr sz="1100" b="0" u="sng">
                           <a:solidFill>
                             <a:srgbClr val="77777A"/>
                           </a:solidFill>
                           <a:latin typeface="Calibri"/>
+                          <a:hlinkClick r:id="rId7"/>
                         </a:rPr>
                         <a:t>DEV-426</a:t>
                       </a:r>
@@ -17874,11 +17912,12 @@
                         </a:spcAft>
                       </a:pPr>
                       <a:r>
-                        <a:rPr sz="1100" b="0">
+                        <a:rPr sz="1100" b="0" u="sng">
                           <a:solidFill>
                             <a:srgbClr val="77777A"/>
                           </a:solidFill>
                           <a:latin typeface="Calibri"/>
+                          <a:hlinkClick r:id="rId8"/>
                         </a:rPr>
                         <a:t>DEFPROD-3711</a:t>
                       </a:r>
@@ -18177,7 +18216,7 @@
         </p:nvSpPr>
         <p:spPr>
           <a:xfrm>
-            <a:off x="561441" y="330098"/>
+            <a:off x="533095" y="330098"/>
             <a:ext cx="7772400" cy="411480"/>
           </a:xfrm>
           <a:prstGeom prst="rect">
@@ -18624,11 +18663,12 @@
                         </a:spcAft>
                       </a:pPr>
                       <a:r>
-                        <a:rPr sz="1100" b="0">
+                        <a:rPr sz="1100" b="0" u="sng">
                           <a:solidFill>
                             <a:srgbClr val="77777A"/>
                           </a:solidFill>
                           <a:latin typeface="Calibri"/>
+                          <a:hlinkClick r:id="rId3"/>
                         </a:rPr>
                         <a:t>FTR-12144</a:t>
                       </a:r>
@@ -18935,11 +18975,12 @@
                         </a:spcAft>
                       </a:pPr>
                       <a:r>
-                        <a:rPr sz="1100" b="0">
+                        <a:rPr sz="1100" b="0" u="sng">
                           <a:solidFill>
                             <a:srgbClr val="77777A"/>
                           </a:solidFill>
                           <a:latin typeface="Calibri"/>
+                          <a:hlinkClick r:id="rId4"/>
                         </a:rPr>
                         <a:t>DEFPROD-9230</a:t>
                       </a:r>

</xml_diff>

<commit_message>
Set presentation theme hyperlink color to gray (#77777A)
PowerPoint overrides run-level font color for hyperlinks with the theme
hlink/folHlink colors (default blue). Update the theme so gray links
render correctly.

Co-authored-by: Artem Kostin <kostin.artem@gmail.com>
</commit_message>
<xml_diff>
--- a/Дефекты_и_разработки_по_Пилоту.pptx
+++ b/Дефекты_и_разработки_по_Пилоту.pptx
@@ -19263,10 +19263,10 @@
         <a:srgbClr val="F79646"/>
       </a:accent6>
       <a:hlink>
-        <a:srgbClr val="0000FF"/>
+        <a:srgbClr val="77777A"/>
       </a:hlink>
       <a:folHlink>
-        <a:srgbClr val="800080"/>
+        <a:srgbClr val="77777A"/>
       </a:folHlink>
     </a:clrScheme>
     <a:fontScheme name="Office">

</xml_diff>

<commit_message>
Add MICHURIN PowerPoint theme template and apply module
Define Office color scheme and fonts from cherkizovo-presentations.md,
add michurin_theme.apply_michurin_theme() for runtime theme application,
create_michurin_template.py to build assets/MICHURIN.pptx, and use the
theme in generate_presentation.py.

Co-authored-by: Artem Kostin <kostin.artem@gmail.com>
</commit_message>
<xml_diff>
--- a/Дефекты_и_разработки_по_Пилоту.pptx
+++ b/Дефекты_и_разработки_по_Пилоту.pptx
@@ -19229,49 +19229,49 @@
 </file>
 
 <file path=ppt/theme/theme1.xml><?xml version="1.0" encoding="utf-8"?>
-<a:theme xmlns:a="http://schemas.openxmlformats.org/drawingml/2006/main" name="Office Theme">
+<a:theme xmlns:a="http://schemas.openxmlformats.org/drawingml/2006/main" name="МИЧУРИН">
   <a:themeElements>
-    <a:clrScheme name="Office">
+    <a:clrScheme name="МИЧУРИН">
       <a:dk1>
-        <a:sysClr val="windowText" lastClr="000000"/>
+        <a:srgbClr val="000000"/>
       </a:dk1>
       <a:lt1>
-        <a:sysClr val="window" lastClr="FFFFFF"/>
+        <a:srgbClr val="FFFFFF"/>
       </a:lt1>
       <a:dk2>
-        <a:srgbClr val="1F497D"/>
+        <a:srgbClr val="454547"/>
       </a:dk2>
       <a:lt2>
-        <a:srgbClr val="EEECE1"/>
+        <a:srgbClr val="F8E7E8"/>
       </a:lt2>
       <a:accent1>
-        <a:srgbClr val="4F81BD"/>
+        <a:srgbClr val="D70036"/>
       </a:accent1>
       <a:accent2>
-        <a:srgbClr val="C0504D"/>
+        <a:srgbClr val="AF182E"/>
       </a:accent2>
       <a:accent3>
-        <a:srgbClr val="9BBB59"/>
+        <a:srgbClr val="199646"/>
       </a:accent3>
       <a:accent4>
-        <a:srgbClr val="8064A2"/>
+        <a:srgbClr val="831223"/>
       </a:accent4>
       <a:accent5>
-        <a:srgbClr val="4BACC6"/>
+        <a:srgbClr val="F0929F"/>
       </a:accent5>
       <a:accent6>
-        <a:srgbClr val="F79646"/>
+        <a:srgbClr val="8AEE8D"/>
       </a:accent6>
       <a:hlink>
-        <a:srgbClr val="0000FF"/>
+        <a:srgbClr val="77777A"/>
       </a:hlink>
       <a:folHlink>
-        <a:srgbClr val="800080"/>
+        <a:srgbClr val="454547"/>
       </a:folHlink>
     </a:clrScheme>
-    <a:fontScheme name="Office">
+    <a:fontScheme name="МИЧУРИН">
       <a:majorFont>
-        <a:latin typeface="Calibri"/>
+        <a:latin typeface="Verdana"/>
         <a:ea typeface=""/>
         <a:cs typeface=""/>
         <a:font script="Jpan" typeface="ＭＳ Ｐゴシック"/>
@@ -19306,7 +19306,7 @@
         <a:font script="Geor" typeface="Sylfaen"/>
       </a:majorFont>
       <a:minorFont>
-        <a:latin typeface="Calibri"/>
+        <a:latin typeface="Verdana"/>
         <a:ea typeface=""/>
         <a:cs typeface=""/>
         <a:font script="Jpan" typeface="ＭＳ Ｐゴシック"/>

</xml_diff>